<commit_message>
Update PPT: add slide 15 with live demo prompts for future extensions
Co-Authored-By: Claude Sonnet 4.6 <noreply@anthropic.com>
</commit_message>
<xml_diff>
--- a/ClaudeCode_ShinesoftIntro.pptx
+++ b/ClaudeCode_ShinesoftIntro.pptx
@@ -4,6 +4,9 @@
   <p:sldMasterIdLst>
     <p:sldMasterId id="2147483648" r:id="rId1"/>
   </p:sldMasterIdLst>
+  <p:notesMasterIdLst>
+    <p:notesMasterId r:id="rId18"/>
+  </p:notesMasterIdLst>
   <p:sldIdLst>
     <p:sldId id="256" r:id="rId2"/>
     <p:sldId id="257" r:id="rId3"/>
@@ -22,9 +25,6 @@
     <p:sldId id="270" r:id="rId16"/>
     <p:sldId id="271" r:id="rId17"/>
   </p:sldIdLst>
-  <p:notesMasterIdLst>
-    <p:notesMasterId r:id="rId18"/>
-  </p:notesMasterIdLst>
   <p:sldSz cx="12192000" cy="6858000"/>
   <p:notesSz cx="6858000" cy="12192000"/>
   <p:defaultTextStyle>
@@ -119,6 +119,11 @@
       </a:defRPr>
     </a:lvl9pPr>
   </p:defaultTextStyle>
+  <p:extLst>
+    <p:ext uri="{EFAFB233-063F-42B5-8137-9DF3F51BA10A}">
+      <p15:sldGuideLst xmlns:p15="http://schemas.microsoft.com/office/powerpoint/2012/main"/>
+    </p:ext>
+  </p:extLst>
 </p:presentation>
 </file>
 
@@ -144,241 +149,17 @@
           <a:chExt cx="0" cy="0"/>
         </a:xfrm>
       </p:grpSpPr>
-      <p:sp>
-        <p:nvSpPr>
-          <p:cNvPr id="2" name="Header Placeholder 1"/>
-          <p:cNvSpPr>
-            <a:spLocks noGrp="1"/>
-          </p:cNvSpPr>
-          <p:nvPr>
-            <p:ph type="hdr" sz="quarter"/>
-          </p:nvPr>
-        </p:nvSpPr>
-        <p:spPr>
-          <a:xfrm>
-            <a:off x="0" y="0"/>
-            <a:ext cx="2971800" cy="458788"/>
-          </a:xfrm>
-          <a:prstGeom prst="rect">
-            <a:avLst/>
-          </a:prstGeom>
-        </p:spPr>
-        <p:txBody>
-          <a:bodyPr vert="horz" lIns="91440" tIns="45720" rIns="91440" bIns="45720" rtlCol="0"/>
-          <a:lstStyle>
-            <a:lvl1pPr algn="l">
-              <a:defRPr sz="1200"/>
-            </a:lvl1pPr>
-          </a:lstStyle>
-          <a:p>
-            <a:endParaRPr lang="en-US"/>
-          </a:p>
-        </p:txBody>
-      </p:sp>
-      <p:sp>
-        <p:nvSpPr>
-          <p:cNvPr id="3" name="Date Placeholder 2"/>
-          <p:cNvSpPr>
-            <a:spLocks noGrp="1"/>
-          </p:cNvSpPr>
-          <p:nvPr>
-            <p:ph type="dt" idx="1"/>
-          </p:nvPr>
-        </p:nvSpPr>
-        <p:spPr>
-          <a:xfrm>
-            <a:off x="3884613" y="0"/>
-            <a:ext cx="2971800" cy="458788"/>
-          </a:xfrm>
-          <a:prstGeom prst="rect">
-            <a:avLst/>
-          </a:prstGeom>
-        </p:spPr>
-        <p:txBody>
-          <a:bodyPr vert="horz" lIns="91440" tIns="45720" rIns="91440" bIns="45720" rtlCol="0"/>
-          <a:lstStyle>
-            <a:lvl1pPr algn="r">
-              <a:defRPr sz="1200"/>
-            </a:lvl1pPr>
-          </a:lstStyle>
-          <a:p>
-            <a:fld id="{5282F153-3F37-0F45-9E97-73ACFA13230C}" type="datetimeFigureOut">
-              <a:rPr lang="en-US"/>
-              <a:t>7/23/19</a:t>
-            </a:fld>
-            <a:endParaRPr lang="en-US"/>
-          </a:p>
-        </p:txBody>
-      </p:sp>
-      <p:sp>
-        <p:nvSpPr>
-          <p:cNvPr id="4" name="Slide Image Placeholder 3"/>
-          <p:cNvSpPr>
-            <a:spLocks noGrp="1" noRot="1" noChangeAspect="1"/>
-          </p:cNvSpPr>
-          <p:nvPr>
-            <p:ph type="sldImg" idx="2"/>
-          </p:nvPr>
-        </p:nvSpPr>
-        <p:spPr>
-          <a:xfrm>
-            <a:off x="685800" y="1143000"/>
-            <a:ext cx="5486400" cy="3086100"/>
-          </a:xfrm>
-          <a:prstGeom prst="rect">
-            <a:avLst/>
-          </a:prstGeom>
-          <a:noFill/>
-          <a:ln w="12700">
-            <a:solidFill>
-              <a:prstClr val="black"/>
-            </a:solidFill>
-          </a:ln>
-        </p:spPr>
-        <p:txBody>
-          <a:bodyPr vert="horz" lIns="91440" tIns="45720" rIns="91440" bIns="45720" rtlCol="0" anchor="ctr"/>
-          <a:lstStyle/>
-          <a:p>
-            <a:endParaRPr lang="en-US"/>
-          </a:p>
-        </p:txBody>
-      </p:sp>
-      <p:sp>
-        <p:nvSpPr>
-          <p:cNvPr id="5" name="Notes Placeholder 4"/>
-          <p:cNvSpPr>
-            <a:spLocks noGrp="1"/>
-          </p:cNvSpPr>
-          <p:nvPr>
-            <p:ph type="body" sz="quarter" idx="3"/>
-          </p:nvPr>
-        </p:nvSpPr>
-        <p:spPr>
-          <a:xfrm>
-            <a:off x="685800" y="4400550"/>
-            <a:ext cx="5486400" cy="3600450"/>
-          </a:xfrm>
-          <a:prstGeom prst="rect">
-            <a:avLst/>
-          </a:prstGeom>
-        </p:spPr>
-        <p:txBody>
-          <a:bodyPr vert="horz" lIns="91440" tIns="45720" rIns="91440" bIns="45720" rtlCol="0"/>
-          <a:lstStyle/>
-          <a:p>
-            <a:pPr lvl="0"/>
-            <a:r>
-              <a:rPr lang="en-US"/>
-              <a:t>Click to edit Master text styles</a:t>
-            </a:r>
-          </a:p>
-          <a:p>
-            <a:pPr lvl="1"/>
-            <a:r>
-              <a:rPr lang="en-US"/>
-              <a:t>Second level</a:t>
-            </a:r>
-          </a:p>
-          <a:p>
-            <a:pPr lvl="2"/>
-            <a:r>
-              <a:rPr lang="en-US"/>
-              <a:t>Third level</a:t>
-            </a:r>
-          </a:p>
-          <a:p>
-            <a:pPr lvl="3"/>
-            <a:r>
-              <a:rPr lang="en-US"/>
-              <a:t>Fourth level</a:t>
-            </a:r>
-          </a:p>
-          <a:p>
-            <a:pPr lvl="4"/>
-            <a:r>
-              <a:rPr lang="en-US"/>
-              <a:t>Fifth level</a:t>
-            </a:r>
-          </a:p>
-        </p:txBody>
-      </p:sp>
-      <p:sp>
-        <p:nvSpPr>
-          <p:cNvPr id="6" name="Footer Placeholder 5"/>
-          <p:cNvSpPr>
-            <a:spLocks noGrp="1"/>
-          </p:cNvSpPr>
-          <p:nvPr>
-            <p:ph type="ftr" sz="quarter" idx="4"/>
-          </p:nvPr>
-        </p:nvSpPr>
-        <p:spPr>
-          <a:xfrm>
-            <a:off x="0" y="8685213"/>
-            <a:ext cx="2971800" cy="458787"/>
-          </a:xfrm>
-          <a:prstGeom prst="rect">
-            <a:avLst/>
-          </a:prstGeom>
-        </p:spPr>
-        <p:txBody>
-          <a:bodyPr vert="horz" lIns="91440" tIns="45720" rIns="91440" bIns="45720" rtlCol="0" anchor="b"/>
-          <a:lstStyle>
-            <a:lvl1pPr algn="l">
-              <a:defRPr sz="1200"/>
-            </a:lvl1pPr>
-          </a:lstStyle>
-          <a:p>
-            <a:endParaRPr lang="en-US"/>
-          </a:p>
-        </p:txBody>
-      </p:sp>
-      <p:sp>
-        <p:nvSpPr>
-          <p:cNvPr id="7" name="Slide Number Placeholder 6"/>
-          <p:cNvSpPr>
-            <a:spLocks noGrp="1"/>
-          </p:cNvSpPr>
-          <p:nvPr>
-            <p:ph type="sldNum" sz="quarter" idx="5"/>
-          </p:nvPr>
-        </p:nvSpPr>
-        <p:spPr>
-          <a:xfrm>
-            <a:off x="3884613" y="8685213"/>
-            <a:ext cx="2971800" cy="458787"/>
-          </a:xfrm>
-          <a:prstGeom prst="rect">
-            <a:avLst/>
-          </a:prstGeom>
-        </p:spPr>
-        <p:txBody>
-          <a:bodyPr vert="horz" lIns="91440" tIns="45720" rIns="91440" bIns="45720" rtlCol="0" anchor="b"/>
-          <a:lstStyle>
-            <a:lvl1pPr algn="r">
-              <a:defRPr sz="1200"/>
-            </a:lvl1pPr>
-          </a:lstStyle>
-          <a:p>
-            <a:fld id="{CE5E9CC1-C706-0F49-92D6-E571CC5EEA8F}" type="slidenum">
-              <a:rPr lang="en-US"/>
-              <a:t>‹#›</a:t>
-            </a:fld>
-            <a:endParaRPr lang="en-US"/>
-          </a:p>
-        </p:txBody>
-      </p:sp>
     </p:spTree>
     <p:extLst>
       <p:ext uri="{BB962C8B-B14F-4D97-AF65-F5344CB8AC3E}">
-        <p14:creationId xmlns:p14="http://schemas.microsoft.com/office/powerpoint/2010/main" val="1024086991"/>
+        <p14:creationId xmlns:p14="http://schemas.microsoft.com/office/powerpoint/2010/main" val="2343070913"/>
       </p:ext>
     </p:extLst>
   </p:cSld>
   <p:clrMap bg1="lt1" tx1="dk1" bg2="lt2" tx2="dk2" accent1="accent1" accent2="accent2" accent3="accent3" accent4="accent4" accent5="accent5" accent6="accent6" hlink="hlink" folHlink="folHlink"/>
   <p:notesStyle>
     <a:lvl1pPr marL="0" algn="l" defTabSz="914400" rtl="0" eaLnBrk="1" latinLnBrk="0" hangingPunct="1">
-      <a:defRPr sz="1200" kern="1200">
+      <a:defRPr kumimoji="1" sz="1200" kern="1200">
         <a:solidFill>
           <a:schemeClr val="tx1"/>
         </a:solidFill>
@@ -388,7 +169,7 @@
       </a:defRPr>
     </a:lvl1pPr>
     <a:lvl2pPr marL="457200" algn="l" defTabSz="914400" rtl="0" eaLnBrk="1" latinLnBrk="0" hangingPunct="1">
-      <a:defRPr sz="1200" kern="1200">
+      <a:defRPr kumimoji="1" sz="1200" kern="1200">
         <a:solidFill>
           <a:schemeClr val="tx1"/>
         </a:solidFill>
@@ -398,7 +179,7 @@
       </a:defRPr>
     </a:lvl2pPr>
     <a:lvl3pPr marL="914400" algn="l" defTabSz="914400" rtl="0" eaLnBrk="1" latinLnBrk="0" hangingPunct="1">
-      <a:defRPr sz="1200" kern="1200">
+      <a:defRPr kumimoji="1" sz="1200" kern="1200">
         <a:solidFill>
           <a:schemeClr val="tx1"/>
         </a:solidFill>
@@ -408,7 +189,7 @@
       </a:defRPr>
     </a:lvl3pPr>
     <a:lvl4pPr marL="1371600" algn="l" defTabSz="914400" rtl="0" eaLnBrk="1" latinLnBrk="0" hangingPunct="1">
-      <a:defRPr sz="1200" kern="1200">
+      <a:defRPr kumimoji="1" sz="1200" kern="1200">
         <a:solidFill>
           <a:schemeClr val="tx1"/>
         </a:solidFill>
@@ -418,7 +199,7 @@
       </a:defRPr>
     </a:lvl4pPr>
     <a:lvl5pPr marL="1828800" algn="l" defTabSz="914400" rtl="0" eaLnBrk="1" latinLnBrk="0" hangingPunct="1">
-      <a:defRPr sz="1200" kern="1200">
+      <a:defRPr kumimoji="1" sz="1200" kern="1200">
         <a:solidFill>
           <a:schemeClr val="tx1"/>
         </a:solidFill>
@@ -428,7 +209,7 @@
       </a:defRPr>
     </a:lvl5pPr>
     <a:lvl6pPr marL="2286000" algn="l" defTabSz="914400" rtl="0" eaLnBrk="1" latinLnBrk="0" hangingPunct="1">
-      <a:defRPr sz="1200" kern="1200">
+      <a:defRPr kumimoji="1" sz="1200" kern="1200">
         <a:solidFill>
           <a:schemeClr val="tx1"/>
         </a:solidFill>
@@ -438,7 +219,7 @@
       </a:defRPr>
     </a:lvl6pPr>
     <a:lvl7pPr marL="2743200" algn="l" defTabSz="914400" rtl="0" eaLnBrk="1" latinLnBrk="0" hangingPunct="1">
-      <a:defRPr sz="1200" kern="1200">
+      <a:defRPr kumimoji="1" sz="1200" kern="1200">
         <a:solidFill>
           <a:schemeClr val="tx1"/>
         </a:solidFill>
@@ -448,7 +229,7 @@
       </a:defRPr>
     </a:lvl7pPr>
     <a:lvl8pPr marL="3200400" algn="l" defTabSz="914400" rtl="0" eaLnBrk="1" latinLnBrk="0" hangingPunct="1">
-      <a:defRPr sz="1200" kern="1200">
+      <a:defRPr kumimoji="1" sz="1200" kern="1200">
         <a:solidFill>
           <a:schemeClr val="tx1"/>
         </a:solidFill>
@@ -458,7 +239,7 @@
       </a:defRPr>
     </a:lvl8pPr>
     <a:lvl9pPr marL="3657600" algn="l" defTabSz="914400" rtl="0" eaLnBrk="1" latinLnBrk="0" hangingPunct="1">
-      <a:defRPr sz="1200" kern="1200">
+      <a:defRPr kumimoji="1" sz="1200" kern="1200">
         <a:solidFill>
           <a:schemeClr val="tx1"/>
         </a:solidFill>
@@ -515,10 +296,6 @@
           <a:bodyPr/>
           <a:lstStyle/>
           <a:p>
-            <a:r>
-              <a:rPr lang="en-US" dirty="0"/>
-              <a:t/>
-            </a:r>
             <a:endParaRPr lang="en-US" dirty="0"/>
           </a:p>
         </p:txBody>
@@ -603,10 +380,6 @@
           <a:bodyPr/>
           <a:lstStyle/>
           <a:p>
-            <a:r>
-              <a:rPr lang="en-US" dirty="0"/>
-              <a:t/>
-            </a:r>
             <a:endParaRPr lang="en-US" dirty="0"/>
           </a:p>
         </p:txBody>
@@ -691,10 +464,6 @@
           <a:bodyPr/>
           <a:lstStyle/>
           <a:p>
-            <a:r>
-              <a:rPr lang="en-US" dirty="0"/>
-              <a:t/>
-            </a:r>
             <a:endParaRPr lang="en-US" dirty="0"/>
           </a:p>
         </p:txBody>
@@ -779,10 +548,6 @@
           <a:bodyPr/>
           <a:lstStyle/>
           <a:p>
-            <a:r>
-              <a:rPr lang="en-US" dirty="0"/>
-              <a:t/>
-            </a:r>
             <a:endParaRPr lang="en-US" dirty="0"/>
           </a:p>
         </p:txBody>
@@ -867,10 +632,6 @@
           <a:bodyPr/>
           <a:lstStyle/>
           <a:p>
-            <a:r>
-              <a:rPr lang="en-US" dirty="0"/>
-              <a:t/>
-            </a:r>
             <a:endParaRPr lang="en-US" dirty="0"/>
           </a:p>
         </p:txBody>
@@ -955,10 +716,6 @@
           <a:bodyPr/>
           <a:lstStyle/>
           <a:p>
-            <a:r>
-              <a:rPr lang="en-US" dirty="0"/>
-              <a:t/>
-            </a:r>
             <a:endParaRPr lang="en-US" dirty="0"/>
           </a:p>
         </p:txBody>
@@ -1043,10 +800,6 @@
           <a:bodyPr/>
           <a:lstStyle/>
           <a:p>
-            <a:r>
-              <a:rPr lang="en-US" dirty="0"/>
-              <a:t/>
-            </a:r>
             <a:endParaRPr lang="en-US" dirty="0"/>
           </a:p>
         </p:txBody>
@@ -1131,10 +884,6 @@
           <a:bodyPr/>
           <a:lstStyle/>
           <a:p>
-            <a:r>
-              <a:rPr lang="en-US" dirty="0"/>
-              <a:t/>
-            </a:r>
             <a:endParaRPr lang="en-US" dirty="0"/>
           </a:p>
         </p:txBody>
@@ -1219,10 +968,6 @@
           <a:bodyPr/>
           <a:lstStyle/>
           <a:p>
-            <a:r>
-              <a:rPr lang="en-US" dirty="0"/>
-              <a:t/>
-            </a:r>
             <a:endParaRPr lang="en-US" dirty="0"/>
           </a:p>
         </p:txBody>
@@ -1307,10 +1052,6 @@
           <a:bodyPr/>
           <a:lstStyle/>
           <a:p>
-            <a:r>
-              <a:rPr lang="en-US" dirty="0"/>
-              <a:t/>
-            </a:r>
             <a:endParaRPr lang="en-US" dirty="0"/>
           </a:p>
         </p:txBody>
@@ -1395,10 +1136,6 @@
           <a:bodyPr/>
           <a:lstStyle/>
           <a:p>
-            <a:r>
-              <a:rPr lang="en-US" dirty="0"/>
-              <a:t/>
-            </a:r>
             <a:endParaRPr lang="en-US" dirty="0"/>
           </a:p>
         </p:txBody>
@@ -1483,10 +1220,6 @@
           <a:bodyPr/>
           <a:lstStyle/>
           <a:p>
-            <a:r>
-              <a:rPr lang="en-US" dirty="0"/>
-              <a:t/>
-            </a:r>
             <a:endParaRPr lang="en-US" dirty="0"/>
           </a:p>
         </p:txBody>
@@ -1571,10 +1304,6 @@
           <a:bodyPr/>
           <a:lstStyle/>
           <a:p>
-            <a:r>
-              <a:rPr lang="en-US" dirty="0"/>
-              <a:t/>
-            </a:r>
             <a:endParaRPr lang="en-US" dirty="0"/>
           </a:p>
         </p:txBody>
@@ -1659,10 +1388,6 @@
           <a:bodyPr/>
           <a:lstStyle/>
           <a:p>
-            <a:r>
-              <a:rPr lang="en-US" dirty="0"/>
-              <a:t/>
-            </a:r>
             <a:endParaRPr lang="en-US" dirty="0"/>
           </a:p>
         </p:txBody>
@@ -1747,10 +1472,6 @@
           <a:bodyPr/>
           <a:lstStyle/>
           <a:p>
-            <a:r>
-              <a:rPr lang="en-US" dirty="0"/>
-              <a:t/>
-            </a:r>
             <a:endParaRPr lang="en-US" dirty="0"/>
           </a:p>
         </p:txBody>
@@ -1835,10 +1556,6 @@
           <a:bodyPr/>
           <a:lstStyle/>
           <a:p>
-            <a:r>
-              <a:rPr lang="en-US" dirty="0"/>
-              <a:t/>
-            </a:r>
             <a:endParaRPr lang="en-US" dirty="0"/>
           </a:p>
         </p:txBody>
@@ -1912,6 +1629,11 @@
 <file path=ppt/slideMasters/slideMaster1.xml><?xml version="1.0" encoding="utf-8"?>
 <p:sldMaster xmlns:a="http://schemas.openxmlformats.org/drawingml/2006/main" xmlns:r="http://schemas.openxmlformats.org/officeDocument/2006/relationships" xmlns:p="http://schemas.openxmlformats.org/presentationml/2006/main">
   <p:cSld>
+    <p:bg>
+      <p:bgRef idx="1001">
+        <a:schemeClr val="bg1"/>
+      </p:bgRef>
+    </p:bg>
     <p:spTree>
       <p:nvGrpSpPr>
         <p:cNvPr id="1" name=""/>
@@ -2194,6 +1916,7 @@
         <a:solidFill>
           <a:srgbClr val="2C4A3E"/>
         </a:solidFill>
+        <a:effectLst/>
       </p:bgPr>
     </p:bg>
     <p:spTree>
@@ -2281,7 +2004,7 @@
           <a:bodyPr wrap="square" rtlCol="0" anchor="ctr"/>
           <a:lstStyle/>
           <a:p>
-            <a:pPr algn="ctr" indent="0" marL="0">
+            <a:pPr marL="0" indent="0" algn="ctr">
               <a:buNone/>
             </a:pPr>
             <a:r>
@@ -2298,7 +2021,7 @@
             <a:endParaRPr lang="en-US" sz="3600" dirty="0"/>
           </a:p>
           <a:p>
-            <a:pPr algn="ctr" indent="0" marL="0">
+            <a:pPr marL="0" indent="0" algn="ctr">
               <a:buNone/>
             </a:pPr>
             <a:r>
@@ -2337,7 +2060,7 @@
           <a:bodyPr wrap="square" rtlCol="0" anchor="ctr"/>
           <a:lstStyle/>
           <a:p>
-            <a:pPr algn="ctr" indent="0" marL="0">
+            <a:pPr marL="0" indent="0" algn="ctr">
               <a:buNone/>
             </a:pPr>
             <a:r>
@@ -2376,7 +2099,7 @@
           <a:bodyPr wrap="square" rtlCol="0" anchor="ctr"/>
           <a:lstStyle/>
           <a:p>
-            <a:pPr algn="ctr" indent="0" marL="0">
+            <a:pPr marL="0" indent="0" algn="ctr">
               <a:buNone/>
             </a:pPr>
             <a:r>
@@ -2410,6 +2133,7 @@
         <a:solidFill>
           <a:srgbClr val="FAF8F5"/>
         </a:solidFill>
+        <a:effectLst/>
       </p:bgPr>
     </p:bg>
     <p:spTree>
@@ -2472,7 +2196,7 @@
           <a:bodyPr wrap="square" rtlCol="0" anchor="ctr"/>
           <a:lstStyle/>
           <a:p>
-            <a:pPr indent="0" marL="0">
+            <a:pPr marL="0" indent="0">
               <a:buNone/>
             </a:pPr>
             <a:r>
@@ -2561,7 +2285,7 @@
           <a:bodyPr wrap="square" rtlCol="0" anchor="ctr"/>
           <a:lstStyle/>
           <a:p>
-            <a:pPr algn="ctr" indent="0" marL="0">
+            <a:pPr marL="0" indent="0" algn="ctr">
               <a:buNone/>
             </a:pPr>
             <a:r>
@@ -2625,7 +2349,7 @@
           <a:bodyPr wrap="square" rtlCol="0" anchor="ctr"/>
           <a:lstStyle/>
           <a:p>
-            <a:pPr algn="ctr" indent="0" marL="0">
+            <a:pPr marL="0" indent="0" algn="ctr">
               <a:buNone/>
             </a:pPr>
             <a:r>
@@ -2642,7 +2366,7 @@
             <a:endParaRPr lang="en-US" sz="1200" dirty="0"/>
           </a:p>
           <a:p>
-            <a:pPr algn="ctr" indent="0" marL="0">
+            <a:pPr marL="0" indent="0" algn="ctr">
               <a:buNone/>
             </a:pPr>
             <a:r>
@@ -2706,7 +2430,7 @@
           <a:bodyPr wrap="square" rtlCol="0" anchor="ctr"/>
           <a:lstStyle/>
           <a:p>
-            <a:pPr algn="ctr" indent="0" marL="0">
+            <a:pPr marL="0" indent="0" algn="ctr">
               <a:buNone/>
             </a:pPr>
             <a:r>
@@ -2770,7 +2494,7 @@
           <a:bodyPr wrap="square" rtlCol="0" anchor="ctr"/>
           <a:lstStyle/>
           <a:p>
-            <a:pPr algn="ctr" indent="0" marL="0">
+            <a:pPr marL="0" indent="0" algn="ctr">
               <a:buNone/>
             </a:pPr>
             <a:r>
@@ -2787,7 +2511,7 @@
             <a:endParaRPr lang="en-US" sz="1200" dirty="0"/>
           </a:p>
           <a:p>
-            <a:pPr algn="ctr" indent="0" marL="0">
+            <a:pPr marL="0" indent="0" algn="ctr">
               <a:buNone/>
             </a:pPr>
             <a:r>
@@ -2851,7 +2575,7 @@
           <a:bodyPr wrap="square" rtlCol="0" anchor="ctr"/>
           <a:lstStyle/>
           <a:p>
-            <a:pPr algn="ctr" indent="0" marL="0">
+            <a:pPr marL="0" indent="0" algn="ctr">
               <a:buNone/>
             </a:pPr>
             <a:r>
@@ -2915,7 +2639,7 @@
           <a:bodyPr wrap="square" rtlCol="0" anchor="ctr"/>
           <a:lstStyle/>
           <a:p>
-            <a:pPr algn="ctr" indent="0" marL="0">
+            <a:pPr marL="0" indent="0" algn="ctr">
               <a:buNone/>
             </a:pPr>
             <a:r>
@@ -2932,7 +2656,7 @@
             <a:endParaRPr lang="en-US" sz="1200" dirty="0"/>
           </a:p>
           <a:p>
-            <a:pPr algn="ctr" indent="0" marL="0">
+            <a:pPr marL="0" indent="0" algn="ctr">
               <a:buNone/>
             </a:pPr>
             <a:r>
@@ -2996,7 +2720,7 @@
           <a:bodyPr wrap="square" rtlCol="0" anchor="ctr"/>
           <a:lstStyle/>
           <a:p>
-            <a:pPr algn="ctr" indent="0" marL="0">
+            <a:pPr marL="0" indent="0" algn="ctr">
               <a:buNone/>
             </a:pPr>
             <a:r>
@@ -3060,7 +2784,7 @@
           <a:bodyPr wrap="square" rtlCol="0" anchor="ctr"/>
           <a:lstStyle/>
           <a:p>
-            <a:pPr algn="ctr" indent="0" marL="0">
+            <a:pPr marL="0" indent="0" algn="ctr">
               <a:buNone/>
             </a:pPr>
             <a:r>
@@ -3077,7 +2801,7 @@
             <a:endParaRPr lang="en-US" sz="1200" dirty="0"/>
           </a:p>
           <a:p>
-            <a:pPr algn="ctr" indent="0" marL="0">
+            <a:pPr marL="0" indent="0" algn="ctr">
               <a:buNone/>
             </a:pPr>
             <a:r>
@@ -3141,7 +2865,7 @@
           <a:bodyPr wrap="square" rtlCol="0" anchor="ctr"/>
           <a:lstStyle/>
           <a:p>
-            <a:pPr algn="ctr" indent="0" marL="0">
+            <a:pPr marL="0" indent="0" algn="ctr">
               <a:buNone/>
             </a:pPr>
             <a:r>
@@ -3205,7 +2929,7 @@
           <a:bodyPr wrap="square" rtlCol="0" anchor="ctr"/>
           <a:lstStyle/>
           <a:p>
-            <a:pPr algn="ctr" indent="0" marL="0">
+            <a:pPr marL="0" indent="0" algn="ctr">
               <a:buNone/>
             </a:pPr>
             <a:r>
@@ -3222,7 +2946,7 @@
             <a:endParaRPr lang="en-US" sz="1200" dirty="0"/>
           </a:p>
           <a:p>
-            <a:pPr algn="ctr" indent="0" marL="0">
+            <a:pPr marL="0" indent="0" algn="ctr">
               <a:buNone/>
             </a:pPr>
             <a:r>
@@ -3286,7 +3010,7 @@
           <a:bodyPr wrap="square" rtlCol="0" anchor="ctr"/>
           <a:lstStyle/>
           <a:p>
-            <a:pPr algn="ctr" indent="0" marL="0">
+            <a:pPr marL="0" indent="0" algn="ctr">
               <a:buNone/>
             </a:pPr>
             <a:r>
@@ -3350,7 +3074,7 @@
           <a:bodyPr wrap="square" rtlCol="0" anchor="ctr"/>
           <a:lstStyle/>
           <a:p>
-            <a:pPr algn="ctr" indent="0" marL="0">
+            <a:pPr marL="0" indent="0" algn="ctr">
               <a:buNone/>
             </a:pPr>
             <a:r>
@@ -3367,7 +3091,7 @@
             <a:endParaRPr lang="en-US" sz="1200" dirty="0"/>
           </a:p>
           <a:p>
-            <a:pPr algn="ctr" indent="0" marL="0">
+            <a:pPr marL="0" indent="0" algn="ctr">
               <a:buNone/>
             </a:pPr>
             <a:r>
@@ -3406,7 +3130,7 @@
           <a:bodyPr wrap="square" rtlCol="0" anchor="ctr"/>
           <a:lstStyle/>
           <a:p>
-            <a:pPr algn="ctr" indent="0" marL="0">
+            <a:pPr marL="0" indent="0" algn="ctr">
               <a:buNone/>
             </a:pPr>
             <a:r>
@@ -3440,6 +3164,7 @@
         <a:solidFill>
           <a:srgbClr val="FAF8F5"/>
         </a:solidFill>
+        <a:effectLst/>
       </p:bgPr>
     </p:bg>
     <p:spTree>
@@ -3502,7 +3227,7 @@
           <a:bodyPr wrap="square" rtlCol="0" anchor="ctr"/>
           <a:lstStyle/>
           <a:p>
-            <a:pPr indent="0" marL="0">
+            <a:pPr marL="0" indent="0">
               <a:buNone/>
             </a:pPr>
             <a:r>
@@ -3566,7 +3291,7 @@
           <a:bodyPr wrap="square" rtlCol="0" anchor="ctr"/>
           <a:lstStyle/>
           <a:p>
-            <a:pPr indent="0" marL="0">
+            <a:pPr marL="0" indent="0">
               <a:buNone/>
             </a:pPr>
             <a:r>
@@ -3630,7 +3355,7 @@
           <a:bodyPr wrap="square" rtlCol="0" anchor="ctr"/>
           <a:lstStyle/>
           <a:p>
-            <a:pPr indent="0" marL="0">
+            <a:pPr marL="0" indent="0">
               <a:buNone/>
             </a:pPr>
             <a:r>
@@ -3647,7 +3372,7 @@
             <a:endParaRPr lang="en-US" sz="1100" dirty="0"/>
           </a:p>
           <a:p>
-            <a:pPr indent="0" marL="0">
+            <a:pPr marL="0" indent="0">
               <a:buNone/>
             </a:pPr>
             <a:r>
@@ -3686,7 +3411,7 @@
           <a:bodyPr wrap="square" rtlCol="0" anchor="ctr"/>
           <a:lstStyle/>
           <a:p>
-            <a:pPr indent="0" marL="0">
+            <a:pPr marL="0" indent="0">
               <a:buNone/>
             </a:pPr>
             <a:r>
@@ -3725,7 +3450,7 @@
           <a:bodyPr wrap="square" rtlCol="0" anchor="ctr"/>
           <a:lstStyle/>
           <a:p>
-            <a:pPr indent="0" marL="0">
+            <a:pPr marL="0" indent="0">
               <a:buNone/>
             </a:pPr>
             <a:r>
@@ -3764,7 +3489,7 @@
           <a:bodyPr wrap="square" rtlCol="0" anchor="ctr"/>
           <a:lstStyle/>
           <a:p>
-            <a:pPr indent="0" marL="0">
+            <a:pPr marL="0" indent="0">
               <a:buNone/>
             </a:pPr>
             <a:r>
@@ -3803,7 +3528,7 @@
           <a:bodyPr wrap="square" rtlCol="0" anchor="ctr"/>
           <a:lstStyle/>
           <a:p>
-            <a:pPr indent="0" marL="0">
+            <a:pPr marL="0" indent="0">
               <a:buNone/>
             </a:pPr>
             <a:r>
@@ -3842,7 +3567,7 @@
           <a:bodyPr wrap="square" rtlCol="0" anchor="ctr"/>
           <a:lstStyle/>
           <a:p>
-            <a:pPr indent="0" marL="0">
+            <a:pPr marL="0" indent="0">
               <a:buNone/>
             </a:pPr>
             <a:r>
@@ -3881,7 +3606,7 @@
           <a:bodyPr wrap="square" rtlCol="0" anchor="ctr"/>
           <a:lstStyle/>
           <a:p>
-            <a:pPr indent="0" marL="0">
+            <a:pPr marL="0" indent="0">
               <a:buNone/>
             </a:pPr>
             <a:r>
@@ -3945,7 +3670,7 @@
           <a:bodyPr wrap="square" rtlCol="0" anchor="ctr"/>
           <a:lstStyle/>
           <a:p>
-            <a:pPr algn="ctr" indent="0" marL="0">
+            <a:pPr marL="0" indent="0" algn="ctr">
               <a:buNone/>
             </a:pPr>
             <a:r>
@@ -3979,6 +3704,7 @@
         <a:solidFill>
           <a:srgbClr val="FAF8F5"/>
         </a:solidFill>
+        <a:effectLst/>
       </p:bgPr>
     </p:bg>
     <p:spTree>
@@ -4041,7 +3767,7 @@
           <a:bodyPr wrap="square" rtlCol="0" anchor="ctr"/>
           <a:lstStyle/>
           <a:p>
-            <a:pPr indent="0" marL="0">
+            <a:pPr marL="0" indent="0">
               <a:buNone/>
             </a:pPr>
             <a:r>
@@ -4130,7 +3856,7 @@
           <a:bodyPr wrap="square" rtlCol="0" anchor="ctr"/>
           <a:lstStyle/>
           <a:p>
-            <a:pPr indent="0" marL="0">
+            <a:pPr marL="0" indent="0">
               <a:buNone/>
             </a:pPr>
             <a:r>
@@ -4171,9 +3897,27 @@
             <a:tbl>
               <a:tblPr/>
               <a:tblGrid>
-                <a:gridCol w="1097280"/>
-                <a:gridCol w="2743200"/>
-                <a:gridCol w="1463040"/>
+                <a:gridCol w="1097280">
+                  <a:extLst>
+                    <a:ext uri="{9D8B030D-6E8A-4147-A177-3AD203B41FA5}">
+                      <a16:colId xmlns:a16="http://schemas.microsoft.com/office/drawing/2014/main" val="20000"/>
+                    </a:ext>
+                  </a:extLst>
+                </a:gridCol>
+                <a:gridCol w="2743200">
+                  <a:extLst>
+                    <a:ext uri="{9D8B030D-6E8A-4147-A177-3AD203B41FA5}">
+                      <a16:colId xmlns:a16="http://schemas.microsoft.com/office/drawing/2014/main" val="20001"/>
+                    </a:ext>
+                  </a:extLst>
+                </a:gridCol>
+                <a:gridCol w="1463040">
+                  <a:extLst>
+                    <a:ext uri="{9D8B030D-6E8A-4147-A177-3AD203B41FA5}">
+                      <a16:colId xmlns:a16="http://schemas.microsoft.com/office/drawing/2014/main" val="20002"/>
+                    </a:ext>
+                  </a:extLst>
+                </a:gridCol>
               </a:tblGrid>
               <a:tr h="475488">
                 <a:tc>
@@ -4181,7 +3925,7 @@
                     <a:bodyPr/>
                     <a:lstStyle/>
                     <a:p>
-                      <a:pPr indent="0" marL="0">
+                      <a:pPr marL="0" indent="0">
                         <a:buNone/>
                       </a:pPr>
                       <a:r>
@@ -4202,7 +3946,7 @@
                       </a:endParaRPr>
                     </a:p>
                   </a:txBody>
-                  <a:tcPr marL="91440" marR="91440" marT="45720" marB="45720">
+                  <a:tcPr>
                     <a:lnL w="12700" cap="flat" cmpd="sng" algn="ctr">
                       <a:solidFill>
                         <a:srgbClr val="2C4A3E"/>
@@ -4249,7 +3993,7 @@
                     <a:bodyPr/>
                     <a:lstStyle/>
                     <a:p>
-                      <a:pPr indent="0" marL="0">
+                      <a:pPr marL="0" indent="0">
                         <a:buNone/>
                       </a:pPr>
                       <a:r>
@@ -4270,7 +4014,7 @@
                       </a:endParaRPr>
                     </a:p>
                   </a:txBody>
-                  <a:tcPr marL="91440" marR="91440" marT="45720" marB="45720">
+                  <a:tcPr>
                     <a:lnL w="12700" cap="flat" cmpd="sng" algn="ctr">
                       <a:solidFill>
                         <a:srgbClr val="2C4A3E"/>
@@ -4317,7 +4061,7 @@
                     <a:bodyPr/>
                     <a:lstStyle/>
                     <a:p>
-                      <a:pPr indent="0" marL="0">
+                      <a:pPr marL="0" indent="0">
                         <a:buNone/>
                       </a:pPr>
                       <a:r>
@@ -4338,7 +4082,7 @@
                       </a:endParaRPr>
                     </a:p>
                   </a:txBody>
-                  <a:tcPr marL="91440" marR="91440" marT="45720" marB="45720">
+                  <a:tcPr>
                     <a:lnL w="12700" cap="flat" cmpd="sng" algn="ctr">
                       <a:solidFill>
                         <a:srgbClr val="2C4A3E"/>
@@ -4380,6 +4124,11 @@
                     </a:solidFill>
                   </a:tcPr>
                 </a:tc>
+                <a:extLst>
+                  <a:ext uri="{0D108BD9-81ED-4DB2-BD59-A6C34878D82A}">
+                    <a16:rowId xmlns:a16="http://schemas.microsoft.com/office/drawing/2014/main" val="10000"/>
+                  </a:ext>
+                </a:extLst>
               </a:tr>
               <a:tr h="475488">
                 <a:tc>
@@ -4387,7 +4136,7 @@
                     <a:bodyPr/>
                     <a:lstStyle/>
                     <a:p>
-                      <a:pPr indent="0" marL="0">
+                      <a:pPr marL="0" indent="0">
                         <a:buNone/>
                       </a:pPr>
                       <a:r>
@@ -4408,7 +4157,7 @@
                       </a:endParaRPr>
                     </a:p>
                   </a:txBody>
-                  <a:tcPr marL="91440" marR="91440" marT="45720" marB="45720">
+                  <a:tcPr>
                     <a:lnL w="12700" cap="flat" cmpd="sng" algn="ctr">
                       <a:solidFill>
                         <a:srgbClr val="2C4A3E"/>
@@ -4455,7 +4204,7 @@
                     <a:bodyPr/>
                     <a:lstStyle/>
                     <a:p>
-                      <a:pPr indent="0" marL="0">
+                      <a:pPr marL="0" indent="0">
                         <a:buNone/>
                       </a:pPr>
                       <a:r>
@@ -4476,7 +4225,7 @@
                       </a:endParaRPr>
                     </a:p>
                   </a:txBody>
-                  <a:tcPr marL="91440" marR="91440" marT="45720" marB="45720">
+                  <a:tcPr>
                     <a:lnL w="12700" cap="flat" cmpd="sng" algn="ctr">
                       <a:solidFill>
                         <a:srgbClr val="2C4A3E"/>
@@ -4523,7 +4272,7 @@
                     <a:bodyPr/>
                     <a:lstStyle/>
                     <a:p>
-                      <a:pPr indent="0" marL="0">
+                      <a:pPr marL="0" indent="0">
                         <a:buNone/>
                       </a:pPr>
                       <a:r>
@@ -4544,7 +4293,7 @@
                       </a:endParaRPr>
                     </a:p>
                   </a:txBody>
-                  <a:tcPr marL="91440" marR="91440" marT="45720" marB="45720">
+                  <a:tcPr>
                     <a:lnL w="12700" cap="flat" cmpd="sng" algn="ctr">
                       <a:solidFill>
                         <a:srgbClr val="2C4A3E"/>
@@ -4586,6 +4335,11 @@
                     </a:solidFill>
                   </a:tcPr>
                 </a:tc>
+                <a:extLst>
+                  <a:ext uri="{0D108BD9-81ED-4DB2-BD59-A6C34878D82A}">
+                    <a16:rowId xmlns:a16="http://schemas.microsoft.com/office/drawing/2014/main" val="10001"/>
+                  </a:ext>
+                </a:extLst>
               </a:tr>
               <a:tr h="475488">
                 <a:tc>
@@ -4593,7 +4347,7 @@
                     <a:bodyPr/>
                     <a:lstStyle/>
                     <a:p>
-                      <a:pPr indent="0" marL="0">
+                      <a:pPr marL="0" indent="0">
                         <a:buNone/>
                       </a:pPr>
                       <a:r>
@@ -4614,7 +4368,7 @@
                       </a:endParaRPr>
                     </a:p>
                   </a:txBody>
-                  <a:tcPr marL="91440" marR="91440" marT="45720" marB="45720">
+                  <a:tcPr>
                     <a:lnL w="12700" cap="flat" cmpd="sng" algn="ctr">
                       <a:solidFill>
                         <a:srgbClr val="2C4A3E"/>
@@ -4661,7 +4415,7 @@
                     <a:bodyPr/>
                     <a:lstStyle/>
                     <a:p>
-                      <a:pPr indent="0" marL="0">
+                      <a:pPr marL="0" indent="0">
                         <a:buNone/>
                       </a:pPr>
                       <a:r>
@@ -4682,7 +4436,7 @@
                       </a:endParaRPr>
                     </a:p>
                   </a:txBody>
-                  <a:tcPr marL="91440" marR="91440" marT="45720" marB="45720">
+                  <a:tcPr>
                     <a:lnL w="12700" cap="flat" cmpd="sng" algn="ctr">
                       <a:solidFill>
                         <a:srgbClr val="2C4A3E"/>
@@ -4729,7 +4483,7 @@
                     <a:bodyPr/>
                     <a:lstStyle/>
                     <a:p>
-                      <a:pPr indent="0" marL="0">
+                      <a:pPr marL="0" indent="0">
                         <a:buNone/>
                       </a:pPr>
                       <a:r>
@@ -4750,7 +4504,7 @@
                       </a:endParaRPr>
                     </a:p>
                   </a:txBody>
-                  <a:tcPr marL="91440" marR="91440" marT="45720" marB="45720">
+                  <a:tcPr>
                     <a:lnL w="12700" cap="flat" cmpd="sng" algn="ctr">
                       <a:solidFill>
                         <a:srgbClr val="2C4A3E"/>
@@ -4792,6 +4546,11 @@
                     </a:solidFill>
                   </a:tcPr>
                 </a:tc>
+                <a:extLst>
+                  <a:ext uri="{0D108BD9-81ED-4DB2-BD59-A6C34878D82A}">
+                    <a16:rowId xmlns:a16="http://schemas.microsoft.com/office/drawing/2014/main" val="10002"/>
+                  </a:ext>
+                </a:extLst>
               </a:tr>
               <a:tr h="475488">
                 <a:tc>
@@ -4799,7 +4558,7 @@
                     <a:bodyPr/>
                     <a:lstStyle/>
                     <a:p>
-                      <a:pPr indent="0" marL="0">
+                      <a:pPr marL="0" indent="0">
                         <a:buNone/>
                       </a:pPr>
                       <a:r>
@@ -4820,7 +4579,7 @@
                       </a:endParaRPr>
                     </a:p>
                   </a:txBody>
-                  <a:tcPr marL="91440" marR="91440" marT="45720" marB="45720">
+                  <a:tcPr>
                     <a:lnL w="12700" cap="flat" cmpd="sng" algn="ctr">
                       <a:solidFill>
                         <a:srgbClr val="2C4A3E"/>
@@ -4867,7 +4626,7 @@
                     <a:bodyPr/>
                     <a:lstStyle/>
                     <a:p>
-                      <a:pPr indent="0" marL="0">
+                      <a:pPr marL="0" indent="0">
                         <a:buNone/>
                       </a:pPr>
                       <a:r>
@@ -4888,7 +4647,7 @@
                       </a:endParaRPr>
                     </a:p>
                   </a:txBody>
-                  <a:tcPr marL="91440" marR="91440" marT="45720" marB="45720">
+                  <a:tcPr>
                     <a:lnL w="12700" cap="flat" cmpd="sng" algn="ctr">
                       <a:solidFill>
                         <a:srgbClr val="2C4A3E"/>
@@ -4935,7 +4694,7 @@
                     <a:bodyPr/>
                     <a:lstStyle/>
                     <a:p>
-                      <a:pPr indent="0" marL="0">
+                      <a:pPr marL="0" indent="0">
                         <a:buNone/>
                       </a:pPr>
                       <a:r>
@@ -4956,7 +4715,7 @@
                       </a:endParaRPr>
                     </a:p>
                   </a:txBody>
-                  <a:tcPr marL="91440" marR="91440" marT="45720" marB="45720">
+                  <a:tcPr>
                     <a:lnL w="12700" cap="flat" cmpd="sng" algn="ctr">
                       <a:solidFill>
                         <a:srgbClr val="2C4A3E"/>
@@ -4998,6 +4757,11 @@
                     </a:solidFill>
                   </a:tcPr>
                 </a:tc>
+                <a:extLst>
+                  <a:ext uri="{0D108BD9-81ED-4DB2-BD59-A6C34878D82A}">
+                    <a16:rowId xmlns:a16="http://schemas.microsoft.com/office/drawing/2014/main" val="10003"/>
+                  </a:ext>
+                </a:extLst>
               </a:tr>
               <a:tr h="475488">
                 <a:tc>
@@ -5005,7 +4769,7 @@
                     <a:bodyPr/>
                     <a:lstStyle/>
                     <a:p>
-                      <a:pPr indent="0" marL="0">
+                      <a:pPr marL="0" indent="0">
                         <a:buNone/>
                       </a:pPr>
                       <a:r>
@@ -5026,7 +4790,7 @@
                       </a:endParaRPr>
                     </a:p>
                   </a:txBody>
-                  <a:tcPr marL="91440" marR="91440" marT="45720" marB="45720">
+                  <a:tcPr>
                     <a:lnL w="12700" cap="flat" cmpd="sng" algn="ctr">
                       <a:solidFill>
                         <a:srgbClr val="2C4A3E"/>
@@ -5073,7 +4837,7 @@
                     <a:bodyPr/>
                     <a:lstStyle/>
                     <a:p>
-                      <a:pPr indent="0" marL="0">
+                      <a:pPr marL="0" indent="0">
                         <a:buNone/>
                       </a:pPr>
                       <a:r>
@@ -5094,7 +4858,7 @@
                       </a:endParaRPr>
                     </a:p>
                   </a:txBody>
-                  <a:tcPr marL="91440" marR="91440" marT="45720" marB="45720">
+                  <a:tcPr>
                     <a:lnL w="12700" cap="flat" cmpd="sng" algn="ctr">
                       <a:solidFill>
                         <a:srgbClr val="2C4A3E"/>
@@ -5141,7 +4905,7 @@
                     <a:bodyPr/>
                     <a:lstStyle/>
                     <a:p>
-                      <a:pPr indent="0" marL="0">
+                      <a:pPr marL="0" indent="0">
                         <a:buNone/>
                       </a:pPr>
                       <a:r>
@@ -5162,7 +4926,7 @@
                       </a:endParaRPr>
                     </a:p>
                   </a:txBody>
-                  <a:tcPr marL="91440" marR="91440" marT="45720" marB="45720">
+                  <a:tcPr>
                     <a:lnL w="12700" cap="flat" cmpd="sng" algn="ctr">
                       <a:solidFill>
                         <a:srgbClr val="2C4A3E"/>
@@ -5204,6 +4968,11 @@
                     </a:solidFill>
                   </a:tcPr>
                 </a:tc>
+                <a:extLst>
+                  <a:ext uri="{0D108BD9-81ED-4DB2-BD59-A6C34878D82A}">
+                    <a16:rowId xmlns:a16="http://schemas.microsoft.com/office/drawing/2014/main" val="10004"/>
+                  </a:ext>
+                </a:extLst>
               </a:tr>
             </a:tbl>
           </a:graphicData>
@@ -5255,7 +5024,7 @@
           <a:bodyPr wrap="square" rtlCol="0" anchor="ctr"/>
           <a:lstStyle/>
           <a:p>
-            <a:pPr indent="0" marL="0">
+            <a:pPr marL="0" indent="0">
               <a:buNone/>
             </a:pPr>
             <a:r>
@@ -5294,7 +5063,7 @@
           <a:bodyPr wrap="square" rtlCol="0" anchor="ctr"/>
           <a:lstStyle/>
           <a:p>
-            <a:pPr indent="0" marL="0">
+            <a:pPr marL="0" indent="0">
               <a:buNone/>
             </a:pPr>
             <a:r>
@@ -5333,7 +5102,7 @@
           <a:bodyPr wrap="square" rtlCol="0" anchor="ctr"/>
           <a:lstStyle/>
           <a:p>
-            <a:pPr indent="0" marL="0">
+            <a:pPr marL="0" indent="0">
               <a:buNone/>
             </a:pPr>
             <a:r>
@@ -5372,7 +5141,7 @@
           <a:bodyPr wrap="square" rtlCol="0" anchor="ctr"/>
           <a:lstStyle/>
           <a:p>
-            <a:pPr indent="0" marL="0">
+            <a:pPr marL="0" indent="0">
               <a:buNone/>
             </a:pPr>
             <a:r>
@@ -5392,7 +5161,7 @@
       </p:sp>
       <p:sp>
         <p:nvSpPr>
-          <p:cNvPr id="13" name="Text 10"/>
+          <p:cNvPr id="7" name="Text 10"/>
           <p:cNvSpPr/>
           <p:nvPr/>
         </p:nvSpPr>
@@ -5411,7 +5180,7 @@
           <a:bodyPr wrap="square" rtlCol="0" anchor="ctr"/>
           <a:lstStyle/>
           <a:p>
-            <a:pPr indent="0" marL="0">
+            <a:pPr marL="0" indent="0">
               <a:buNone/>
             </a:pPr>
             <a:r>
@@ -5475,7 +5244,7 @@
           <a:bodyPr wrap="square" rtlCol="0" anchor="ctr"/>
           <a:lstStyle/>
           <a:p>
-            <a:pPr algn="ctr" indent="0" marL="0">
+            <a:pPr marL="0" indent="0" algn="ctr">
               <a:buNone/>
             </a:pPr>
             <a:r>
@@ -5492,7 +5261,7 @@
             <a:endParaRPr lang="en-US" sz="1300" dirty="0"/>
           </a:p>
           <a:p>
-            <a:pPr algn="ctr" indent="0" marL="0">
+            <a:pPr marL="0" indent="0" algn="ctr">
               <a:buNone/>
             </a:pPr>
             <a:r>
@@ -5556,7 +5325,7 @@
           <a:bodyPr wrap="square" rtlCol="0" anchor="ctr"/>
           <a:lstStyle/>
           <a:p>
-            <a:pPr algn="ctr" indent="0" marL="0">
+            <a:pPr marL="0" indent="0" algn="ctr">
               <a:buNone/>
             </a:pPr>
             <a:r>
@@ -5590,6 +5359,7 @@
         <a:solidFill>
           <a:srgbClr val="FAF8F5"/>
         </a:solidFill>
+        <a:effectLst/>
       </p:bgPr>
     </p:bg>
     <p:spTree>
@@ -5652,7 +5422,7 @@
           <a:bodyPr wrap="square" rtlCol="0" anchor="ctr"/>
           <a:lstStyle/>
           <a:p>
-            <a:pPr indent="0" marL="0">
+            <a:pPr marL="0" indent="0">
               <a:buNone/>
             </a:pPr>
             <a:r>
@@ -5741,7 +5511,7 @@
           <a:bodyPr wrap="square" rtlCol="0" anchor="ctr"/>
           <a:lstStyle/>
           <a:p>
-            <a:pPr algn="ctr" indent="0" marL="0">
+            <a:pPr marL="0" indent="0" algn="ctr">
               <a:buNone/>
             </a:pPr>
             <a:r>
@@ -5805,7 +5575,7 @@
           <a:bodyPr wrap="square" rtlCol="0" anchor="ctr"/>
           <a:lstStyle/>
           <a:p>
-            <a:pPr algn="ctr" indent="0" marL="0">
+            <a:pPr marL="0" indent="0" algn="ctr">
               <a:buNone/>
             </a:pPr>
             <a:r>
@@ -5844,7 +5614,7 @@
           <a:bodyPr wrap="square" rtlCol="0" anchor="ctr"/>
           <a:lstStyle/>
           <a:p>
-            <a:pPr algn="ctr" indent="0" marL="0">
+            <a:pPr marL="0" indent="0" algn="ctr">
               <a:buNone/>
             </a:pPr>
             <a:r>
@@ -5861,7 +5631,7 @@
             <a:endParaRPr lang="en-US" sz="1100" dirty="0"/>
           </a:p>
           <a:p>
-            <a:pPr algn="ctr" indent="0" marL="0">
+            <a:pPr marL="0" indent="0" algn="ctr">
               <a:buNone/>
             </a:pPr>
             <a:r>
@@ -5900,7 +5670,7 @@
           <a:bodyPr wrap="square" rtlCol="0" anchor="ctr"/>
           <a:lstStyle/>
           <a:p>
-            <a:pPr algn="ctr" indent="0" marL="0">
+            <a:pPr marL="0" indent="0" algn="ctr">
               <a:buNone/>
             </a:pPr>
             <a:r>
@@ -5961,7 +5731,7 @@
           <a:bodyPr wrap="square" rtlCol="0" anchor="ctr"/>
           <a:lstStyle/>
           <a:p>
-            <a:pPr algn="ctr" indent="0" marL="0">
+            <a:pPr marL="0" indent="0" algn="ctr">
               <a:buNone/>
             </a:pPr>
             <a:r>
@@ -6000,7 +5770,7 @@
           <a:bodyPr wrap="square" rtlCol="0" anchor="ctr"/>
           <a:lstStyle/>
           <a:p>
-            <a:pPr algn="ctr" indent="0" marL="0">
+            <a:pPr marL="0" indent="0" algn="ctr">
               <a:buNone/>
             </a:pPr>
             <a:r>
@@ -6017,7 +5787,7 @@
             <a:endParaRPr lang="en-US" sz="1100" dirty="0"/>
           </a:p>
           <a:p>
-            <a:pPr algn="ctr" indent="0" marL="0">
+            <a:pPr marL="0" indent="0" algn="ctr">
               <a:buNone/>
             </a:pPr>
             <a:r>
@@ -6081,7 +5851,7 @@
           <a:bodyPr wrap="square" rtlCol="0" anchor="ctr"/>
           <a:lstStyle/>
           <a:p>
-            <a:pPr algn="ctr" indent="0" marL="0">
+            <a:pPr marL="0" indent="0" algn="ctr">
               <a:buNone/>
             </a:pPr>
             <a:r>
@@ -6145,7 +5915,7 @@
           <a:bodyPr wrap="square" rtlCol="0" anchor="ctr"/>
           <a:lstStyle/>
           <a:p>
-            <a:pPr algn="ctr" indent="0" marL="0">
+            <a:pPr marL="0" indent="0" algn="ctr">
               <a:buNone/>
             </a:pPr>
             <a:r>
@@ -6184,7 +5954,7 @@
           <a:bodyPr wrap="square" rtlCol="0" anchor="ctr"/>
           <a:lstStyle/>
           <a:p>
-            <a:pPr algn="ctr" indent="0" marL="0">
+            <a:pPr marL="0" indent="0" algn="ctr">
               <a:buNone/>
             </a:pPr>
             <a:r>
@@ -6201,7 +5971,7 @@
             <a:endParaRPr lang="en-US" sz="1100" dirty="0"/>
           </a:p>
           <a:p>
-            <a:pPr algn="ctr" indent="0" marL="0">
+            <a:pPr marL="0" indent="0" algn="ctr">
               <a:buNone/>
             </a:pPr>
             <a:r>
@@ -6240,7 +6010,7 @@
           <a:bodyPr wrap="square" rtlCol="0" anchor="ctr"/>
           <a:lstStyle/>
           <a:p>
-            <a:pPr algn="ctr" indent="0" marL="0">
+            <a:pPr marL="0" indent="0" algn="ctr">
               <a:buNone/>
             </a:pPr>
             <a:r>
@@ -6301,7 +6071,7 @@
           <a:bodyPr wrap="square" rtlCol="0" anchor="ctr"/>
           <a:lstStyle/>
           <a:p>
-            <a:pPr algn="ctr" indent="0" marL="0">
+            <a:pPr marL="0" indent="0" algn="ctr">
               <a:buNone/>
             </a:pPr>
             <a:r>
@@ -6340,7 +6110,7 @@
           <a:bodyPr wrap="square" rtlCol="0" anchor="ctr"/>
           <a:lstStyle/>
           <a:p>
-            <a:pPr algn="ctr" indent="0" marL="0">
+            <a:pPr marL="0" indent="0" algn="ctr">
               <a:buNone/>
             </a:pPr>
             <a:r>
@@ -6357,7 +6127,7 @@
             <a:endParaRPr lang="en-US" sz="1100" dirty="0"/>
           </a:p>
           <a:p>
-            <a:pPr algn="ctr" indent="0" marL="0">
+            <a:pPr marL="0" indent="0" algn="ctr">
               <a:buNone/>
             </a:pPr>
             <a:r>
@@ -6421,7 +6191,7 @@
           <a:bodyPr wrap="square" rtlCol="0" anchor="ctr"/>
           <a:lstStyle/>
           <a:p>
-            <a:pPr algn="ctr" indent="0" marL="0">
+            <a:pPr marL="0" indent="0" algn="ctr">
               <a:buNone/>
             </a:pPr>
             <a:r>
@@ -6485,7 +6255,7 @@
           <a:bodyPr wrap="square" rtlCol="0" anchor="ctr"/>
           <a:lstStyle/>
           <a:p>
-            <a:pPr algn="ctr" indent="0" marL="0">
+            <a:pPr marL="0" indent="0" algn="ctr">
               <a:buNone/>
             </a:pPr>
             <a:r>
@@ -6524,7 +6294,7 @@
           <a:bodyPr wrap="square" rtlCol="0" anchor="ctr"/>
           <a:lstStyle/>
           <a:p>
-            <a:pPr algn="ctr" indent="0" marL="0">
+            <a:pPr marL="0" indent="0" algn="ctr">
               <a:buNone/>
             </a:pPr>
             <a:r>
@@ -6541,7 +6311,7 @@
             <a:endParaRPr lang="en-US" sz="1100" dirty="0"/>
           </a:p>
           <a:p>
-            <a:pPr algn="ctr" indent="0" marL="0">
+            <a:pPr marL="0" indent="0" algn="ctr">
               <a:buNone/>
             </a:pPr>
             <a:r>
@@ -6580,7 +6350,7 @@
           <a:bodyPr wrap="square" rtlCol="0" anchor="ctr"/>
           <a:lstStyle/>
           <a:p>
-            <a:pPr algn="ctr" indent="0" marL="0">
+            <a:pPr marL="0" indent="0" algn="ctr">
               <a:buNone/>
             </a:pPr>
             <a:r>
@@ -6641,7 +6411,7 @@
           <a:bodyPr wrap="square" rtlCol="0" anchor="ctr"/>
           <a:lstStyle/>
           <a:p>
-            <a:pPr algn="ctr" indent="0" marL="0">
+            <a:pPr marL="0" indent="0" algn="ctr">
               <a:buNone/>
             </a:pPr>
             <a:r>
@@ -6680,7 +6450,7 @@
           <a:bodyPr wrap="square" rtlCol="0" anchor="ctr"/>
           <a:lstStyle/>
           <a:p>
-            <a:pPr algn="ctr" indent="0" marL="0">
+            <a:pPr marL="0" indent="0" algn="ctr">
               <a:buNone/>
             </a:pPr>
             <a:r>
@@ -6697,7 +6467,7 @@
             <a:endParaRPr lang="en-US" sz="1100" dirty="0"/>
           </a:p>
           <a:p>
-            <a:pPr algn="ctr" indent="0" marL="0">
+            <a:pPr marL="0" indent="0" algn="ctr">
               <a:buNone/>
             </a:pPr>
             <a:r>
@@ -6761,7 +6531,7 @@
           <a:bodyPr wrap="square" rtlCol="0" anchor="ctr"/>
           <a:lstStyle/>
           <a:p>
-            <a:pPr algn="ctr" indent="0" marL="0">
+            <a:pPr marL="0" indent="0" algn="ctr">
               <a:buNone/>
             </a:pPr>
             <a:r>
@@ -6825,7 +6595,7 @@
           <a:bodyPr wrap="square" rtlCol="0" anchor="ctr"/>
           <a:lstStyle/>
           <a:p>
-            <a:pPr algn="ctr" indent="0" marL="0">
+            <a:pPr marL="0" indent="0" algn="ctr">
               <a:buNone/>
             </a:pPr>
             <a:r>
@@ -6864,7 +6634,7 @@
           <a:bodyPr wrap="square" rtlCol="0" anchor="ctr"/>
           <a:lstStyle/>
           <a:p>
-            <a:pPr algn="ctr" indent="0" marL="0">
+            <a:pPr marL="0" indent="0" algn="ctr">
               <a:buNone/>
             </a:pPr>
             <a:r>
@@ -6881,7 +6651,7 @@
             <a:endParaRPr lang="en-US" sz="1100" dirty="0"/>
           </a:p>
           <a:p>
-            <a:pPr algn="ctr" indent="0" marL="0">
+            <a:pPr marL="0" indent="0" algn="ctr">
               <a:buNone/>
             </a:pPr>
             <a:r>
@@ -6920,7 +6690,7 @@
           <a:bodyPr wrap="square" rtlCol="0" anchor="ctr"/>
           <a:lstStyle/>
           <a:p>
-            <a:pPr algn="ctr" indent="0" marL="0">
+            <a:pPr marL="0" indent="0" algn="ctr">
               <a:buNone/>
             </a:pPr>
             <a:r>
@@ -6981,7 +6751,7 @@
           <a:bodyPr wrap="square" rtlCol="0" anchor="ctr"/>
           <a:lstStyle/>
           <a:p>
-            <a:pPr algn="ctr" indent="0" marL="0">
+            <a:pPr marL="0" indent="0" algn="ctr">
               <a:buNone/>
             </a:pPr>
             <a:r>
@@ -7020,7 +6790,7 @@
           <a:bodyPr wrap="square" rtlCol="0" anchor="ctr"/>
           <a:lstStyle/>
           <a:p>
-            <a:pPr algn="ctr" indent="0" marL="0">
+            <a:pPr marL="0" indent="0" algn="ctr">
               <a:buNone/>
             </a:pPr>
             <a:r>
@@ -7037,7 +6807,7 @@
             <a:endParaRPr lang="en-US" sz="1100" dirty="0"/>
           </a:p>
           <a:p>
-            <a:pPr algn="ctr" indent="0" marL="0">
+            <a:pPr marL="0" indent="0" algn="ctr">
               <a:buNone/>
             </a:pPr>
             <a:r>
@@ -7101,7 +6871,7 @@
           <a:bodyPr wrap="square" rtlCol="0" anchor="ctr"/>
           <a:lstStyle/>
           <a:p>
-            <a:pPr algn="ctr" indent="0" marL="0">
+            <a:pPr marL="0" indent="0" algn="ctr">
               <a:buNone/>
             </a:pPr>
             <a:r>
@@ -7135,6 +6905,7 @@
         <a:solidFill>
           <a:srgbClr val="FAF8F5"/>
         </a:solidFill>
+        <a:effectLst/>
       </p:bgPr>
     </p:bg>
     <p:spTree>
@@ -7197,7 +6968,7 @@
           <a:bodyPr wrap="square" rtlCol="0" anchor="ctr"/>
           <a:lstStyle/>
           <a:p>
-            <a:pPr indent="0" marL="0">
+            <a:pPr marL="0" indent="0">
               <a:buNone/>
             </a:pPr>
             <a:r>
@@ -7286,7 +7057,7 @@
           <a:bodyPr wrap="square" rtlCol="0" anchor="ctr"/>
           <a:lstStyle/>
           <a:p>
-            <a:pPr algn="ctr" indent="0" marL="0">
+            <a:pPr marL="0" indent="0" algn="ctr">
               <a:buNone/>
             </a:pPr>
             <a:r>
@@ -7350,7 +7121,7 @@
           <a:bodyPr wrap="square" rtlCol="0" anchor="ctr"/>
           <a:lstStyle/>
           <a:p>
-            <a:pPr indent="0" marL="0">
+            <a:pPr marL="0" indent="0">
               <a:buNone/>
             </a:pPr>
             <a:r>
@@ -7389,7 +7160,7 @@
           <a:bodyPr wrap="square" rtlCol="0" anchor="ctr"/>
           <a:lstStyle/>
           <a:p>
-            <a:pPr indent="0" marL="0">
+            <a:pPr marL="0" indent="0">
               <a:buNone/>
             </a:pPr>
             <a:r>
@@ -7428,7 +7199,7 @@
           <a:bodyPr wrap="square" rtlCol="0" anchor="ctr"/>
           <a:lstStyle/>
           <a:p>
-            <a:pPr indent="0" marL="0">
+            <a:pPr marL="0" indent="0">
               <a:buNone/>
             </a:pPr>
             <a:r>
@@ -7467,7 +7238,7 @@
           <a:bodyPr wrap="square" rtlCol="0" anchor="ctr"/>
           <a:lstStyle/>
           <a:p>
-            <a:pPr indent="0" marL="0">
+            <a:pPr marL="0" indent="0">
               <a:buNone/>
             </a:pPr>
             <a:r>
@@ -7506,7 +7277,7 @@
           <a:bodyPr wrap="square" rtlCol="0" anchor="ctr"/>
           <a:lstStyle/>
           <a:p>
-            <a:pPr indent="0" marL="0">
+            <a:pPr marL="0" indent="0">
               <a:buNone/>
             </a:pPr>
             <a:r>
@@ -7545,7 +7316,7 @@
           <a:bodyPr wrap="square" rtlCol="0" anchor="ctr"/>
           <a:lstStyle/>
           <a:p>
-            <a:pPr indent="0" marL="0">
+            <a:pPr marL="0" indent="0">
               <a:buNone/>
             </a:pPr>
             <a:r>
@@ -7584,7 +7355,7 @@
           <a:bodyPr wrap="square" rtlCol="0" anchor="ctr"/>
           <a:lstStyle/>
           <a:p>
-            <a:pPr indent="0" marL="0">
+            <a:pPr marL="0" indent="0">
               <a:buNone/>
             </a:pPr>
             <a:r>
@@ -7623,7 +7394,7 @@
           <a:bodyPr wrap="square" rtlCol="0" anchor="ctr"/>
           <a:lstStyle/>
           <a:p>
-            <a:pPr indent="0" marL="0">
+            <a:pPr marL="0" indent="0">
               <a:buNone/>
             </a:pPr>
             <a:r>
@@ -7687,7 +7458,7 @@
           <a:bodyPr wrap="square" rtlCol="0" anchor="ctr"/>
           <a:lstStyle/>
           <a:p>
-            <a:pPr algn="ctr" indent="0" marL="0">
+            <a:pPr marL="0" indent="0" algn="ctr">
               <a:buNone/>
             </a:pPr>
             <a:r>
@@ -7751,7 +7522,7 @@
           <a:bodyPr wrap="square" rtlCol="0" anchor="ctr"/>
           <a:lstStyle/>
           <a:p>
-            <a:pPr indent="0" marL="0">
+            <a:pPr marL="0" indent="0">
               <a:buNone/>
             </a:pPr>
             <a:r>
@@ -7790,7 +7561,7 @@
           <a:bodyPr wrap="square" rtlCol="0" anchor="ctr"/>
           <a:lstStyle/>
           <a:p>
-            <a:pPr indent="0" marL="0">
+            <a:pPr marL="0" indent="0">
               <a:buNone/>
             </a:pPr>
             <a:r>
@@ -7829,7 +7600,7 @@
           <a:bodyPr wrap="square" rtlCol="0" anchor="ctr"/>
           <a:lstStyle/>
           <a:p>
-            <a:pPr indent="0" marL="0">
+            <a:pPr marL="0" indent="0">
               <a:buNone/>
             </a:pPr>
             <a:r>
@@ -7868,7 +7639,7 @@
           <a:bodyPr wrap="square" rtlCol="0" anchor="ctr"/>
           <a:lstStyle/>
           <a:p>
-            <a:pPr indent="0" marL="0">
+            <a:pPr marL="0" indent="0">
               <a:buNone/>
             </a:pPr>
             <a:r>
@@ -7907,7 +7678,7 @@
           <a:bodyPr wrap="square" rtlCol="0" anchor="ctr"/>
           <a:lstStyle/>
           <a:p>
-            <a:pPr indent="0" marL="0">
+            <a:pPr marL="0" indent="0">
               <a:buNone/>
             </a:pPr>
             <a:r>
@@ -7971,7 +7742,7 @@
           <a:bodyPr wrap="square" rtlCol="0" anchor="ctr"/>
           <a:lstStyle/>
           <a:p>
-            <a:pPr algn="ctr" indent="0" marL="0">
+            <a:pPr marL="0" indent="0" algn="ctr">
               <a:buNone/>
             </a:pPr>
             <a:r>
@@ -8005,6 +7776,7 @@
         <a:solidFill>
           <a:srgbClr val="FAF8F5"/>
         </a:solidFill>
+        <a:effectLst/>
       </p:bgPr>
     </p:bg>
     <p:spTree>
@@ -8067,7 +7839,7 @@
           <a:bodyPr wrap="square" rtlCol="0" anchor="ctr"/>
           <a:lstStyle/>
           <a:p>
-            <a:pPr indent="0" marL="0">
+            <a:pPr marL="0" indent="0">
               <a:buNone/>
             </a:pPr>
             <a:r>
@@ -8131,7 +7903,7 @@
           <a:bodyPr wrap="square" rtlCol="0" anchor="ctr"/>
           <a:lstStyle/>
           <a:p>
-            <a:pPr indent="0" marL="0">
+            <a:pPr marL="0" indent="0">
               <a:buNone/>
             </a:pPr>
             <a:r>
@@ -8220,7 +7992,7 @@
           <a:bodyPr wrap="square" rtlCol="0" anchor="ctr"/>
           <a:lstStyle/>
           <a:p>
-            <a:pPr algn="ctr" indent="0" marL="0">
+            <a:pPr marL="0" indent="0" algn="ctr">
               <a:buNone/>
             </a:pPr>
             <a:r>
@@ -8256,7 +8028,7 @@
           <a:bodyPr wrap="square" rtlCol="0" anchor="ctr"/>
           <a:lstStyle/>
           <a:p>
-            <a:pPr indent="0" marL="0">
+            <a:pPr marL="0" indent="0">
               <a:buNone/>
             </a:pPr>
             <a:r>
@@ -8295,7 +8067,7 @@
           <a:bodyPr wrap="square" rtlCol="0" anchor="ctr"/>
           <a:lstStyle/>
           <a:p>
-            <a:pPr indent="0" marL="0">
+            <a:pPr marL="0" indent="0">
               <a:buNone/>
             </a:pPr>
             <a:r>
@@ -8312,7 +8084,7 @@
             <a:endParaRPr lang="en-US" sz="1200" dirty="0"/>
           </a:p>
           <a:p>
-            <a:pPr indent="0" marL="0">
+            <a:pPr marL="0" indent="0">
               <a:buNone/>
             </a:pPr>
             <a:r>
@@ -8401,7 +8173,7 @@
           <a:bodyPr wrap="square" rtlCol="0" anchor="ctr"/>
           <a:lstStyle/>
           <a:p>
-            <a:pPr algn="ctr" indent="0" marL="0">
+            <a:pPr marL="0" indent="0" algn="ctr">
               <a:buNone/>
             </a:pPr>
             <a:r>
@@ -8437,7 +8209,7 @@
           <a:bodyPr wrap="square" rtlCol="0" anchor="ctr"/>
           <a:lstStyle/>
           <a:p>
-            <a:pPr indent="0" marL="0">
+            <a:pPr marL="0" indent="0">
               <a:buNone/>
             </a:pPr>
             <a:r>
@@ -8476,7 +8248,7 @@
           <a:bodyPr wrap="square" rtlCol="0" anchor="ctr"/>
           <a:lstStyle/>
           <a:p>
-            <a:pPr indent="0" marL="0">
+            <a:pPr marL="0" indent="0">
               <a:buNone/>
             </a:pPr>
             <a:r>
@@ -8493,7 +8265,7 @@
             <a:endParaRPr lang="en-US" sz="1200" dirty="0"/>
           </a:p>
           <a:p>
-            <a:pPr indent="0" marL="0">
+            <a:pPr marL="0" indent="0">
               <a:buNone/>
             </a:pPr>
             <a:r>
@@ -8532,7 +8304,7 @@
           <a:bodyPr wrap="square" rtlCol="0" anchor="ctr"/>
           <a:lstStyle/>
           <a:p>
-            <a:pPr indent="0" marL="0">
+            <a:pPr marL="0" indent="0">
               <a:buNone/>
             </a:pPr>
             <a:r>
@@ -8596,7 +8368,7 @@
           <a:bodyPr wrap="square" rtlCol="0" anchor="ctr"/>
           <a:lstStyle/>
           <a:p>
-            <a:pPr indent="0" marL="0">
+            <a:pPr marL="0" indent="0">
               <a:buNone/>
             </a:pPr>
             <a:r>
@@ -8613,7 +8385,7 @@
             <a:endParaRPr lang="en-US" sz="1100" dirty="0"/>
           </a:p>
           <a:p>
-            <a:pPr indent="0" marL="0">
+            <a:pPr marL="0" indent="0">
               <a:buNone/>
             </a:pPr>
             <a:r>
@@ -8630,7 +8402,7 @@
             <a:endParaRPr lang="en-US" sz="1100" dirty="0"/>
           </a:p>
           <a:p>
-            <a:pPr indent="0" marL="0">
+            <a:pPr marL="0" indent="0">
               <a:buNone/>
             </a:pPr>
             <a:r>
@@ -8647,7 +8419,7 @@
             <a:endParaRPr lang="en-US" sz="1100" dirty="0"/>
           </a:p>
           <a:p>
-            <a:pPr indent="0" marL="0">
+            <a:pPr marL="0" indent="0">
               <a:buNone/>
             </a:pPr>
             <a:r>
@@ -8686,7 +8458,7 @@
           <a:bodyPr wrap="square" rtlCol="0" anchor="ctr"/>
           <a:lstStyle/>
           <a:p>
-            <a:pPr indent="0" marL="0">
+            <a:pPr marL="0" indent="0">
               <a:buNone/>
             </a:pPr>
             <a:r>
@@ -8750,7 +8522,7 @@
           <a:bodyPr wrap="square" rtlCol="0" anchor="ctr"/>
           <a:lstStyle/>
           <a:p>
-            <a:pPr indent="0" marL="0">
+            <a:pPr marL="0" indent="0">
               <a:buNone/>
             </a:pPr>
             <a:r>
@@ -8767,7 +8539,7 @@
             <a:endParaRPr lang="en-US" sz="1100" dirty="0"/>
           </a:p>
           <a:p>
-            <a:pPr indent="0" marL="0">
+            <a:pPr marL="0" indent="0">
               <a:buNone/>
             </a:pPr>
             <a:r>
@@ -8784,7 +8556,7 @@
             <a:endParaRPr lang="en-US" sz="1100" dirty="0"/>
           </a:p>
           <a:p>
-            <a:pPr indent="0" marL="0">
+            <a:pPr marL="0" indent="0">
               <a:buNone/>
             </a:pPr>
             <a:r>
@@ -8801,7 +8573,7 @@
             <a:endParaRPr lang="en-US" sz="1100" dirty="0"/>
           </a:p>
           <a:p>
-            <a:pPr indent="0" marL="0">
+            <a:pPr marL="0" indent="0">
               <a:buNone/>
             </a:pPr>
             <a:r>
@@ -8865,7 +8637,7 @@
           <a:bodyPr wrap="square" rtlCol="0" anchor="ctr"/>
           <a:lstStyle/>
           <a:p>
-            <a:pPr algn="ctr" indent="0" marL="0">
+            <a:pPr marL="0" indent="0" algn="ctr">
               <a:buNone/>
             </a:pPr>
             <a:r>
@@ -8899,6 +8671,7 @@
         <a:solidFill>
           <a:srgbClr val="FAF8F5"/>
         </a:solidFill>
+        <a:effectLst/>
       </p:bgPr>
     </p:bg>
     <p:spTree>
@@ -8961,7 +8734,7 @@
           <a:bodyPr wrap="square" rtlCol="0" anchor="ctr"/>
           <a:lstStyle/>
           <a:p>
-            <a:pPr indent="0" marL="0">
+            <a:pPr marL="0" indent="0">
               <a:buNone/>
             </a:pPr>
             <a:r>
@@ -9025,7 +8798,7 @@
           <a:bodyPr wrap="square" rtlCol="0" anchor="ctr"/>
           <a:lstStyle/>
           <a:p>
-            <a:pPr indent="0" marL="0">
+            <a:pPr marL="0" indent="0">
               <a:buNone/>
             </a:pPr>
             <a:r>
@@ -9066,9 +8839,27 @@
             <a:tbl>
               <a:tblPr/>
               <a:tblGrid>
-                <a:gridCol w="2286000"/>
-                <a:gridCol w="1645920"/>
-                <a:gridCol w="2926080"/>
+                <a:gridCol w="2286000">
+                  <a:extLst>
+                    <a:ext uri="{9D8B030D-6E8A-4147-A177-3AD203B41FA5}">
+                      <a16:colId xmlns:a16="http://schemas.microsoft.com/office/drawing/2014/main" val="20000"/>
+                    </a:ext>
+                  </a:extLst>
+                </a:gridCol>
+                <a:gridCol w="1645920">
+                  <a:extLst>
+                    <a:ext uri="{9D8B030D-6E8A-4147-A177-3AD203B41FA5}">
+                      <a16:colId xmlns:a16="http://schemas.microsoft.com/office/drawing/2014/main" val="20001"/>
+                    </a:ext>
+                  </a:extLst>
+                </a:gridCol>
+                <a:gridCol w="2926080">
+                  <a:extLst>
+                    <a:ext uri="{9D8B030D-6E8A-4147-A177-3AD203B41FA5}">
+                      <a16:colId xmlns:a16="http://schemas.microsoft.com/office/drawing/2014/main" val="20002"/>
+                    </a:ext>
+                  </a:extLst>
+                </a:gridCol>
               </a:tblGrid>
               <a:tr h="420624">
                 <a:tc>
@@ -9076,7 +8867,7 @@
                     <a:bodyPr/>
                     <a:lstStyle/>
                     <a:p>
-                      <a:pPr indent="0" marL="0">
+                      <a:pPr marL="0" indent="0">
                         <a:buNone/>
                       </a:pPr>
                       <a:r>
@@ -9097,7 +8888,7 @@
                       </a:endParaRPr>
                     </a:p>
                   </a:txBody>
-                  <a:tcPr marL="91440" marR="91440" marT="45720" marB="45720">
+                  <a:tcPr>
                     <a:lnL w="12700" cap="flat" cmpd="sng" algn="ctr">
                       <a:solidFill>
                         <a:srgbClr val="2C4A3E"/>
@@ -9144,7 +8935,7 @@
                     <a:bodyPr/>
                     <a:lstStyle/>
                     <a:p>
-                      <a:pPr indent="0" marL="0">
+                      <a:pPr marL="0" indent="0">
                         <a:buNone/>
                       </a:pPr>
                       <a:r>
@@ -9165,7 +8956,7 @@
                       </a:endParaRPr>
                     </a:p>
                   </a:txBody>
-                  <a:tcPr marL="91440" marR="91440" marT="45720" marB="45720">
+                  <a:tcPr>
                     <a:lnL w="12700" cap="flat" cmpd="sng" algn="ctr">
                       <a:solidFill>
                         <a:srgbClr val="2C4A3E"/>
@@ -9212,7 +9003,7 @@
                     <a:bodyPr/>
                     <a:lstStyle/>
                     <a:p>
-                      <a:pPr indent="0" marL="0">
+                      <a:pPr marL="0" indent="0">
                         <a:buNone/>
                       </a:pPr>
                       <a:r>
@@ -9233,7 +9024,7 @@
                       </a:endParaRPr>
                     </a:p>
                   </a:txBody>
-                  <a:tcPr marL="91440" marR="91440" marT="45720" marB="45720">
+                  <a:tcPr>
                     <a:lnL w="12700" cap="flat" cmpd="sng" algn="ctr">
                       <a:solidFill>
                         <a:srgbClr val="2C4A3E"/>
@@ -9275,6 +9066,11 @@
                     </a:solidFill>
                   </a:tcPr>
                 </a:tc>
+                <a:extLst>
+                  <a:ext uri="{0D108BD9-81ED-4DB2-BD59-A6C34878D82A}">
+                    <a16:rowId xmlns:a16="http://schemas.microsoft.com/office/drawing/2014/main" val="10000"/>
+                  </a:ext>
+                </a:extLst>
               </a:tr>
               <a:tr h="420624">
                 <a:tc>
@@ -9282,7 +9078,7 @@
                     <a:bodyPr/>
                     <a:lstStyle/>
                     <a:p>
-                      <a:pPr indent="0" marL="0">
+                      <a:pPr marL="0" indent="0">
                         <a:buNone/>
                       </a:pPr>
                       <a:r>
@@ -9303,7 +9099,7 @@
                       </a:endParaRPr>
                     </a:p>
                   </a:txBody>
-                  <a:tcPr marL="91440" marR="91440" marT="45720" marB="45720">
+                  <a:tcPr>
                     <a:lnL w="12700" cap="flat" cmpd="sng" algn="ctr">
                       <a:solidFill>
                         <a:srgbClr val="2C4A3E"/>
@@ -9350,7 +9146,7 @@
                     <a:bodyPr/>
                     <a:lstStyle/>
                     <a:p>
-                      <a:pPr indent="0" marL="0">
+                      <a:pPr marL="0" indent="0">
                         <a:buNone/>
                       </a:pPr>
                       <a:r>
@@ -9371,7 +9167,7 @@
                       </a:endParaRPr>
                     </a:p>
                   </a:txBody>
-                  <a:tcPr marL="91440" marR="91440" marT="45720" marB="45720">
+                  <a:tcPr>
                     <a:lnL w="12700" cap="flat" cmpd="sng" algn="ctr">
                       <a:solidFill>
                         <a:srgbClr val="2C4A3E"/>
@@ -9418,7 +9214,7 @@
                     <a:bodyPr/>
                     <a:lstStyle/>
                     <a:p>
-                      <a:pPr indent="0" marL="0">
+                      <a:pPr marL="0" indent="0">
                         <a:buNone/>
                       </a:pPr>
                       <a:r>
@@ -9439,7 +9235,7 @@
                       </a:endParaRPr>
                     </a:p>
                   </a:txBody>
-                  <a:tcPr marL="91440" marR="91440" marT="45720" marB="45720">
+                  <a:tcPr>
                     <a:lnL w="12700" cap="flat" cmpd="sng" algn="ctr">
                       <a:solidFill>
                         <a:srgbClr val="2C4A3E"/>
@@ -9481,6 +9277,11 @@
                     </a:solidFill>
                   </a:tcPr>
                 </a:tc>
+                <a:extLst>
+                  <a:ext uri="{0D108BD9-81ED-4DB2-BD59-A6C34878D82A}">
+                    <a16:rowId xmlns:a16="http://schemas.microsoft.com/office/drawing/2014/main" val="10001"/>
+                  </a:ext>
+                </a:extLst>
               </a:tr>
               <a:tr h="420624">
                 <a:tc>
@@ -9488,7 +9289,7 @@
                     <a:bodyPr/>
                     <a:lstStyle/>
                     <a:p>
-                      <a:pPr indent="0" marL="0">
+                      <a:pPr marL="0" indent="0">
                         <a:buNone/>
                       </a:pPr>
                       <a:r>
@@ -9509,7 +9310,7 @@
                       </a:endParaRPr>
                     </a:p>
                   </a:txBody>
-                  <a:tcPr marL="91440" marR="91440" marT="45720" marB="45720">
+                  <a:tcPr>
                     <a:lnL w="12700" cap="flat" cmpd="sng" algn="ctr">
                       <a:solidFill>
                         <a:srgbClr val="2C4A3E"/>
@@ -9556,7 +9357,7 @@
                     <a:bodyPr/>
                     <a:lstStyle/>
                     <a:p>
-                      <a:pPr indent="0" marL="0">
+                      <a:pPr marL="0" indent="0">
                         <a:buNone/>
                       </a:pPr>
                       <a:r>
@@ -9577,7 +9378,7 @@
                       </a:endParaRPr>
                     </a:p>
                   </a:txBody>
-                  <a:tcPr marL="91440" marR="91440" marT="45720" marB="45720">
+                  <a:tcPr>
                     <a:lnL w="12700" cap="flat" cmpd="sng" algn="ctr">
                       <a:solidFill>
                         <a:srgbClr val="2C4A3E"/>
@@ -9624,7 +9425,7 @@
                     <a:bodyPr/>
                     <a:lstStyle/>
                     <a:p>
-                      <a:pPr indent="0" marL="0">
+                      <a:pPr marL="0" indent="0">
                         <a:buNone/>
                       </a:pPr>
                       <a:r>
@@ -9645,7 +9446,7 @@
                       </a:endParaRPr>
                     </a:p>
                   </a:txBody>
-                  <a:tcPr marL="91440" marR="91440" marT="45720" marB="45720">
+                  <a:tcPr>
                     <a:lnL w="12700" cap="flat" cmpd="sng" algn="ctr">
                       <a:solidFill>
                         <a:srgbClr val="2C4A3E"/>
@@ -9687,6 +9488,11 @@
                     </a:solidFill>
                   </a:tcPr>
                 </a:tc>
+                <a:extLst>
+                  <a:ext uri="{0D108BD9-81ED-4DB2-BD59-A6C34878D82A}">
+                    <a16:rowId xmlns:a16="http://schemas.microsoft.com/office/drawing/2014/main" val="10002"/>
+                  </a:ext>
+                </a:extLst>
               </a:tr>
               <a:tr h="420624">
                 <a:tc>
@@ -9694,7 +9500,7 @@
                     <a:bodyPr/>
                     <a:lstStyle/>
                     <a:p>
-                      <a:pPr indent="0" marL="0">
+                      <a:pPr marL="0" indent="0">
                         <a:buNone/>
                       </a:pPr>
                       <a:r>
@@ -9715,7 +9521,7 @@
                       </a:endParaRPr>
                     </a:p>
                   </a:txBody>
-                  <a:tcPr marL="91440" marR="91440" marT="45720" marB="45720">
+                  <a:tcPr>
                     <a:lnL w="12700" cap="flat" cmpd="sng" algn="ctr">
                       <a:solidFill>
                         <a:srgbClr val="2C4A3E"/>
@@ -9762,7 +9568,7 @@
                     <a:bodyPr/>
                     <a:lstStyle/>
                     <a:p>
-                      <a:pPr indent="0" marL="0">
+                      <a:pPr marL="0" indent="0">
                         <a:buNone/>
                       </a:pPr>
                       <a:r>
@@ -9783,7 +9589,7 @@
                       </a:endParaRPr>
                     </a:p>
                   </a:txBody>
-                  <a:tcPr marL="91440" marR="91440" marT="45720" marB="45720">
+                  <a:tcPr>
                     <a:lnL w="12700" cap="flat" cmpd="sng" algn="ctr">
                       <a:solidFill>
                         <a:srgbClr val="2C4A3E"/>
@@ -9830,7 +9636,7 @@
                     <a:bodyPr/>
                     <a:lstStyle/>
                     <a:p>
-                      <a:pPr indent="0" marL="0">
+                      <a:pPr marL="0" indent="0">
                         <a:buNone/>
                       </a:pPr>
                       <a:r>
@@ -9851,7 +9657,7 @@
                       </a:endParaRPr>
                     </a:p>
                   </a:txBody>
-                  <a:tcPr marL="91440" marR="91440" marT="45720" marB="45720">
+                  <a:tcPr>
                     <a:lnL w="12700" cap="flat" cmpd="sng" algn="ctr">
                       <a:solidFill>
                         <a:srgbClr val="2C4A3E"/>
@@ -9893,6 +9699,11 @@
                     </a:solidFill>
                   </a:tcPr>
                 </a:tc>
+                <a:extLst>
+                  <a:ext uri="{0D108BD9-81ED-4DB2-BD59-A6C34878D82A}">
+                    <a16:rowId xmlns:a16="http://schemas.microsoft.com/office/drawing/2014/main" val="10003"/>
+                  </a:ext>
+                </a:extLst>
               </a:tr>
               <a:tr h="420624">
                 <a:tc>
@@ -9900,7 +9711,7 @@
                     <a:bodyPr/>
                     <a:lstStyle/>
                     <a:p>
-                      <a:pPr indent="0" marL="0">
+                      <a:pPr marL="0" indent="0">
                         <a:buNone/>
                       </a:pPr>
                       <a:r>
@@ -9921,7 +9732,7 @@
                       </a:endParaRPr>
                     </a:p>
                   </a:txBody>
-                  <a:tcPr marL="91440" marR="91440" marT="45720" marB="45720">
+                  <a:tcPr>
                     <a:lnL w="12700" cap="flat" cmpd="sng" algn="ctr">
                       <a:solidFill>
                         <a:srgbClr val="2C4A3E"/>
@@ -9968,7 +9779,7 @@
                     <a:bodyPr/>
                     <a:lstStyle/>
                     <a:p>
-                      <a:pPr indent="0" marL="0">
+                      <a:pPr marL="0" indent="0">
                         <a:buNone/>
                       </a:pPr>
                       <a:r>
@@ -9989,7 +9800,7 @@
                       </a:endParaRPr>
                     </a:p>
                   </a:txBody>
-                  <a:tcPr marL="91440" marR="91440" marT="45720" marB="45720">
+                  <a:tcPr>
                     <a:lnL w="12700" cap="flat" cmpd="sng" algn="ctr">
                       <a:solidFill>
                         <a:srgbClr val="2C4A3E"/>
@@ -10036,7 +9847,7 @@
                     <a:bodyPr/>
                     <a:lstStyle/>
                     <a:p>
-                      <a:pPr indent="0" marL="0">
+                      <a:pPr marL="0" indent="0">
                         <a:buNone/>
                       </a:pPr>
                       <a:r>
@@ -10057,7 +9868,7 @@
                       </a:endParaRPr>
                     </a:p>
                   </a:txBody>
-                  <a:tcPr marL="91440" marR="91440" marT="45720" marB="45720">
+                  <a:tcPr>
                     <a:lnL w="12700" cap="flat" cmpd="sng" algn="ctr">
                       <a:solidFill>
                         <a:srgbClr val="2C4A3E"/>
@@ -10099,6 +9910,11 @@
                     </a:solidFill>
                   </a:tcPr>
                 </a:tc>
+                <a:extLst>
+                  <a:ext uri="{0D108BD9-81ED-4DB2-BD59-A6C34878D82A}">
+                    <a16:rowId xmlns:a16="http://schemas.microsoft.com/office/drawing/2014/main" val="10004"/>
+                  </a:ext>
+                </a:extLst>
               </a:tr>
             </a:tbl>
           </a:graphicData>
@@ -10125,7 +9941,7 @@
           <a:bodyPr wrap="square" rtlCol="0" anchor="ctr"/>
           <a:lstStyle/>
           <a:p>
-            <a:pPr indent="0" marL="0">
+            <a:pPr marL="0" indent="0">
               <a:buNone/>
             </a:pPr>
             <a:r>
@@ -10189,7 +10005,7 @@
           <a:bodyPr wrap="square" rtlCol="0" anchor="ctr"/>
           <a:lstStyle/>
           <a:p>
-            <a:pPr algn="ctr" indent="0" marL="0">
+            <a:pPr marL="0" indent="0" algn="ctr">
               <a:buNone/>
             </a:pPr>
             <a:r>
@@ -10225,7 +10041,7 @@
           <a:bodyPr wrap="square" rtlCol="0" anchor="ctr"/>
           <a:lstStyle/>
           <a:p>
-            <a:pPr indent="0" marL="0">
+            <a:pPr marL="0" indent="0">
               <a:buNone/>
             </a:pPr>
             <a:r>
@@ -10289,7 +10105,7 @@
           <a:bodyPr wrap="square" rtlCol="0" anchor="ctr"/>
           <a:lstStyle/>
           <a:p>
-            <a:pPr algn="ctr" indent="0" marL="0">
+            <a:pPr marL="0" indent="0" algn="ctr">
               <a:buNone/>
             </a:pPr>
             <a:r>
@@ -10325,7 +10141,7 @@
           <a:bodyPr wrap="square" rtlCol="0" anchor="ctr"/>
           <a:lstStyle/>
           <a:p>
-            <a:pPr indent="0" marL="0">
+            <a:pPr marL="0" indent="0">
               <a:buNone/>
             </a:pPr>
             <a:r>
@@ -10389,7 +10205,7 @@
           <a:bodyPr wrap="square" rtlCol="0" anchor="ctr"/>
           <a:lstStyle/>
           <a:p>
-            <a:pPr algn="ctr" indent="0" marL="0">
+            <a:pPr marL="0" indent="0" algn="ctr">
               <a:buNone/>
             </a:pPr>
             <a:r>
@@ -10425,7 +10241,7 @@
           <a:bodyPr wrap="square" rtlCol="0" anchor="ctr"/>
           <a:lstStyle/>
           <a:p>
-            <a:pPr indent="0" marL="0">
+            <a:pPr marL="0" indent="0">
               <a:buNone/>
             </a:pPr>
             <a:r>
@@ -10445,7 +10261,7 @@
       </p:sp>
       <p:sp>
         <p:nvSpPr>
-          <p:cNvPr id="17" name="Shape 14"/>
+          <p:cNvPr id="6" name="Shape 14"/>
           <p:cNvSpPr/>
           <p:nvPr/>
         </p:nvSpPr>
@@ -10489,7 +10305,7 @@
           <a:bodyPr wrap="square" rtlCol="0" anchor="ctr"/>
           <a:lstStyle/>
           <a:p>
-            <a:pPr algn="ctr" indent="0" marL="0">
+            <a:pPr marL="0" indent="0" algn="ctr">
               <a:buNone/>
             </a:pPr>
             <a:r>
@@ -10525,7 +10341,7 @@
           <a:bodyPr wrap="square" rtlCol="0" anchor="ctr"/>
           <a:lstStyle/>
           <a:p>
-            <a:pPr indent="0" marL="0">
+            <a:pPr marL="0" indent="0">
               <a:buNone/>
             </a:pPr>
             <a:r>
@@ -10589,7 +10405,7 @@
           <a:bodyPr wrap="square" rtlCol="0" anchor="ctr"/>
           <a:lstStyle/>
           <a:p>
-            <a:pPr algn="ctr" indent="0" marL="0">
+            <a:pPr marL="0" indent="0" algn="ctr">
               <a:buNone/>
             </a:pPr>
             <a:r>
@@ -10625,7 +10441,7 @@
           <a:bodyPr wrap="square" rtlCol="0" anchor="ctr"/>
           <a:lstStyle/>
           <a:p>
-            <a:pPr indent="0" marL="0">
+            <a:pPr marL="0" indent="0">
               <a:buNone/>
             </a:pPr>
             <a:r>
@@ -10689,7 +10505,7 @@
           <a:bodyPr wrap="square" rtlCol="0" anchor="ctr"/>
           <a:lstStyle/>
           <a:p>
-            <a:pPr algn="ctr" indent="0" marL="0">
+            <a:pPr marL="0" indent="0" algn="ctr">
               <a:buNone/>
             </a:pPr>
             <a:r>
@@ -10728,7 +10544,7 @@
           <a:bodyPr wrap="square" rtlCol="0" anchor="ctr"/>
           <a:lstStyle/>
           <a:p>
-            <a:pPr algn="ctr" indent="0" marL="0">
+            <a:pPr marL="0" indent="0" algn="ctr">
               <a:buNone/>
             </a:pPr>
             <a:r>
@@ -10792,7 +10608,7 @@
           <a:bodyPr wrap="square" rtlCol="0" anchor="ctr"/>
           <a:lstStyle/>
           <a:p>
-            <a:pPr algn="ctr" indent="0" marL="0">
+            <a:pPr marL="0" indent="0" algn="ctr">
               <a:buNone/>
             </a:pPr>
             <a:r>
@@ -10826,6 +10642,7 @@
         <a:solidFill>
           <a:srgbClr val="FAF8F5"/>
         </a:solidFill>
+        <a:effectLst/>
       </p:bgPr>
     </p:bg>
     <p:spTree>
@@ -10888,7 +10705,7 @@
           <a:bodyPr wrap="square" rtlCol="0" anchor="ctr"/>
           <a:lstStyle/>
           <a:p>
-            <a:pPr indent="0" marL="0">
+            <a:pPr marL="0" indent="0">
               <a:buNone/>
             </a:pPr>
             <a:r>
@@ -10952,7 +10769,7 @@
           <a:bodyPr wrap="square" rtlCol="0" anchor="ctr"/>
           <a:lstStyle/>
           <a:p>
-            <a:pPr indent="0" marL="0">
+            <a:pPr marL="0" indent="0">
               <a:buNone/>
             </a:pPr>
             <a:r>
@@ -10972,7 +10789,7 @@
       </p:sp>
       <p:graphicFrame>
         <p:nvGraphicFramePr>
-          <p:cNvPr id="3" name="Table 0"/>
+          <p:cNvPr id="6" name="Table 0"/>
           <p:cNvGraphicFramePr>
             <a:graphicFrameLocks noGrp="1"/>
           </p:cNvGraphicFramePr>
@@ -10993,8 +10810,20 @@
             <a:tbl>
               <a:tblPr/>
               <a:tblGrid>
-                <a:gridCol w="2011680"/>
-                <a:gridCol w="4846320"/>
+                <a:gridCol w="2011680">
+                  <a:extLst>
+                    <a:ext uri="{9D8B030D-6E8A-4147-A177-3AD203B41FA5}">
+                      <a16:colId xmlns:a16="http://schemas.microsoft.com/office/drawing/2014/main" val="20000"/>
+                    </a:ext>
+                  </a:extLst>
+                </a:gridCol>
+                <a:gridCol w="4846320">
+                  <a:extLst>
+                    <a:ext uri="{9D8B030D-6E8A-4147-A177-3AD203B41FA5}">
+                      <a16:colId xmlns:a16="http://schemas.microsoft.com/office/drawing/2014/main" val="20001"/>
+                    </a:ext>
+                  </a:extLst>
+                </a:gridCol>
               </a:tblGrid>
               <a:tr h="457200">
                 <a:tc>
@@ -11002,7 +10831,7 @@
                     <a:bodyPr/>
                     <a:lstStyle/>
                     <a:p>
-                      <a:pPr indent="0" marL="0">
+                      <a:pPr marL="0" indent="0">
                         <a:buNone/>
                       </a:pPr>
                       <a:r>
@@ -11023,7 +10852,7 @@
                       </a:endParaRPr>
                     </a:p>
                   </a:txBody>
-                  <a:tcPr marL="91440" marR="91440" marT="45720" marB="45720">
+                  <a:tcPr>
                     <a:lnL w="12700" cap="flat" cmpd="sng" algn="ctr">
                       <a:solidFill>
                         <a:srgbClr val="2C4A3E"/>
@@ -11070,7 +10899,7 @@
                     <a:bodyPr/>
                     <a:lstStyle/>
                     <a:p>
-                      <a:pPr indent="0" marL="0">
+                      <a:pPr marL="0" indent="0">
                         <a:buNone/>
                       </a:pPr>
                       <a:r>
@@ -11091,7 +10920,7 @@
                       </a:endParaRPr>
                     </a:p>
                   </a:txBody>
-                  <a:tcPr marL="91440" marR="91440" marT="45720" marB="45720">
+                  <a:tcPr>
                     <a:lnL w="12700" cap="flat" cmpd="sng" algn="ctr">
                       <a:solidFill>
                         <a:srgbClr val="2C4A3E"/>
@@ -11133,6 +10962,11 @@
                     </a:solidFill>
                   </a:tcPr>
                 </a:tc>
+                <a:extLst>
+                  <a:ext uri="{0D108BD9-81ED-4DB2-BD59-A6C34878D82A}">
+                    <a16:rowId xmlns:a16="http://schemas.microsoft.com/office/drawing/2014/main" val="10000"/>
+                  </a:ext>
+                </a:extLst>
               </a:tr>
               <a:tr h="457200">
                 <a:tc>
@@ -11140,7 +10974,7 @@
                     <a:bodyPr/>
                     <a:lstStyle/>
                     <a:p>
-                      <a:pPr indent="0" marL="0">
+                      <a:pPr marL="0" indent="0">
                         <a:buNone/>
                       </a:pPr>
                       <a:r>
@@ -11161,7 +10995,7 @@
                       </a:endParaRPr>
                     </a:p>
                   </a:txBody>
-                  <a:tcPr marL="91440" marR="91440" marT="45720" marB="45720">
+                  <a:tcPr>
                     <a:lnL w="12700" cap="flat" cmpd="sng" algn="ctr">
                       <a:solidFill>
                         <a:srgbClr val="2C4A3E"/>
@@ -11208,7 +11042,7 @@
                     <a:bodyPr/>
                     <a:lstStyle/>
                     <a:p>
-                      <a:pPr indent="0" marL="0">
+                      <a:pPr marL="0" indent="0">
                         <a:buNone/>
                       </a:pPr>
                       <a:r>
@@ -11229,7 +11063,7 @@
                       </a:endParaRPr>
                     </a:p>
                   </a:txBody>
-                  <a:tcPr marL="91440" marR="91440" marT="45720" marB="45720">
+                  <a:tcPr>
                     <a:lnL w="12700" cap="flat" cmpd="sng" algn="ctr">
                       <a:solidFill>
                         <a:srgbClr val="2C4A3E"/>
@@ -11271,6 +11105,11 @@
                     </a:solidFill>
                   </a:tcPr>
                 </a:tc>
+                <a:extLst>
+                  <a:ext uri="{0D108BD9-81ED-4DB2-BD59-A6C34878D82A}">
+                    <a16:rowId xmlns:a16="http://schemas.microsoft.com/office/drawing/2014/main" val="10001"/>
+                  </a:ext>
+                </a:extLst>
               </a:tr>
               <a:tr h="457200">
                 <a:tc>
@@ -11278,7 +11117,7 @@
                     <a:bodyPr/>
                     <a:lstStyle/>
                     <a:p>
-                      <a:pPr indent="0" marL="0">
+                      <a:pPr marL="0" indent="0">
                         <a:buNone/>
                       </a:pPr>
                       <a:r>
@@ -11299,7 +11138,7 @@
                       </a:endParaRPr>
                     </a:p>
                   </a:txBody>
-                  <a:tcPr marL="91440" marR="91440" marT="45720" marB="45720">
+                  <a:tcPr>
                     <a:lnL w="12700" cap="flat" cmpd="sng" algn="ctr">
                       <a:solidFill>
                         <a:srgbClr val="2C4A3E"/>
@@ -11346,7 +11185,7 @@
                     <a:bodyPr/>
                     <a:lstStyle/>
                     <a:p>
-                      <a:pPr indent="0" marL="0">
+                      <a:pPr marL="0" indent="0">
                         <a:buNone/>
                       </a:pPr>
                       <a:r>
@@ -11367,7 +11206,7 @@
                       </a:endParaRPr>
                     </a:p>
                   </a:txBody>
-                  <a:tcPr marL="91440" marR="91440" marT="45720" marB="45720">
+                  <a:tcPr>
                     <a:lnL w="12700" cap="flat" cmpd="sng" algn="ctr">
                       <a:solidFill>
                         <a:srgbClr val="2C4A3E"/>
@@ -11409,6 +11248,11 @@
                     </a:solidFill>
                   </a:tcPr>
                 </a:tc>
+                <a:extLst>
+                  <a:ext uri="{0D108BD9-81ED-4DB2-BD59-A6C34878D82A}">
+                    <a16:rowId xmlns:a16="http://schemas.microsoft.com/office/drawing/2014/main" val="10002"/>
+                  </a:ext>
+                </a:extLst>
               </a:tr>
               <a:tr h="457200">
                 <a:tc>
@@ -11416,7 +11260,7 @@
                     <a:bodyPr/>
                     <a:lstStyle/>
                     <a:p>
-                      <a:pPr indent="0" marL="0">
+                      <a:pPr marL="0" indent="0">
                         <a:buNone/>
                       </a:pPr>
                       <a:r>
@@ -11437,7 +11281,7 @@
                       </a:endParaRPr>
                     </a:p>
                   </a:txBody>
-                  <a:tcPr marL="91440" marR="91440" marT="45720" marB="45720">
+                  <a:tcPr>
                     <a:lnL w="12700" cap="flat" cmpd="sng" algn="ctr">
                       <a:solidFill>
                         <a:srgbClr val="2C4A3E"/>
@@ -11484,7 +11328,7 @@
                     <a:bodyPr/>
                     <a:lstStyle/>
                     <a:p>
-                      <a:pPr indent="0" marL="0">
+                      <a:pPr marL="0" indent="0">
                         <a:buNone/>
                       </a:pPr>
                       <a:r>
@@ -11505,7 +11349,7 @@
                       </a:endParaRPr>
                     </a:p>
                   </a:txBody>
-                  <a:tcPr marL="91440" marR="91440" marT="45720" marB="45720">
+                  <a:tcPr>
                     <a:lnL w="12700" cap="flat" cmpd="sng" algn="ctr">
                       <a:solidFill>
                         <a:srgbClr val="2C4A3E"/>
@@ -11547,6 +11391,11 @@
                     </a:solidFill>
                   </a:tcPr>
                 </a:tc>
+                <a:extLst>
+                  <a:ext uri="{0D108BD9-81ED-4DB2-BD59-A6C34878D82A}">
+                    <a16:rowId xmlns:a16="http://schemas.microsoft.com/office/drawing/2014/main" val="10003"/>
+                  </a:ext>
+                </a:extLst>
               </a:tr>
               <a:tr h="457200">
                 <a:tc>
@@ -11554,7 +11403,7 @@
                     <a:bodyPr/>
                     <a:lstStyle/>
                     <a:p>
-                      <a:pPr indent="0" marL="0">
+                      <a:pPr marL="0" indent="0">
                         <a:buNone/>
                       </a:pPr>
                       <a:r>
@@ -11575,7 +11424,7 @@
                       </a:endParaRPr>
                     </a:p>
                   </a:txBody>
-                  <a:tcPr marL="91440" marR="91440" marT="45720" marB="45720">
+                  <a:tcPr>
                     <a:lnL w="12700" cap="flat" cmpd="sng" algn="ctr">
                       <a:solidFill>
                         <a:srgbClr val="2C4A3E"/>
@@ -11622,7 +11471,7 @@
                     <a:bodyPr/>
                     <a:lstStyle/>
                     <a:p>
-                      <a:pPr indent="0" marL="0">
+                      <a:pPr marL="0" indent="0">
                         <a:buNone/>
                       </a:pPr>
                       <a:r>
@@ -11643,7 +11492,7 @@
                       </a:endParaRPr>
                     </a:p>
                   </a:txBody>
-                  <a:tcPr marL="91440" marR="91440" marT="45720" marB="45720">
+                  <a:tcPr>
                     <a:lnL w="12700" cap="flat" cmpd="sng" algn="ctr">
                       <a:solidFill>
                         <a:srgbClr val="2C4A3E"/>
@@ -11685,6 +11534,11 @@
                     </a:solidFill>
                   </a:tcPr>
                 </a:tc>
+                <a:extLst>
+                  <a:ext uri="{0D108BD9-81ED-4DB2-BD59-A6C34878D82A}">
+                    <a16:rowId xmlns:a16="http://schemas.microsoft.com/office/drawing/2014/main" val="10004"/>
+                  </a:ext>
+                </a:extLst>
               </a:tr>
             </a:tbl>
           </a:graphicData>
@@ -11711,7 +11565,7 @@
           <a:bodyPr wrap="square" rtlCol="0" anchor="ctr"/>
           <a:lstStyle/>
           <a:p>
-            <a:pPr indent="0" marL="0">
+            <a:pPr marL="0" indent="0">
               <a:buNone/>
             </a:pPr>
             <a:r>
@@ -11750,7 +11604,7 @@
           <a:bodyPr wrap="square" rtlCol="0" anchor="ctr"/>
           <a:lstStyle/>
           <a:p>
-            <a:pPr indent="0" marL="0">
+            <a:pPr marL="0" indent="0">
               <a:buNone/>
             </a:pPr>
             <a:r>
@@ -11789,7 +11643,7 @@
           <a:bodyPr wrap="square" rtlCol="0" anchor="ctr"/>
           <a:lstStyle/>
           <a:p>
-            <a:pPr indent="0" marL="0">
+            <a:pPr marL="0" indent="0">
               <a:buNone/>
             </a:pPr>
             <a:r>
@@ -11828,7 +11682,7 @@
           <a:bodyPr wrap="square" rtlCol="0" anchor="ctr"/>
           <a:lstStyle/>
           <a:p>
-            <a:pPr indent="0" marL="0">
+            <a:pPr marL="0" indent="0">
               <a:buNone/>
             </a:pPr>
             <a:r>
@@ -11867,7 +11721,7 @@
           <a:bodyPr wrap="square" rtlCol="0" anchor="ctr"/>
           <a:lstStyle/>
           <a:p>
-            <a:pPr indent="0" marL="0">
+            <a:pPr marL="0" indent="0">
               <a:buNone/>
             </a:pPr>
             <a:r>
@@ -11906,7 +11760,7 @@
           <a:bodyPr wrap="square" rtlCol="0" anchor="ctr"/>
           <a:lstStyle/>
           <a:p>
-            <a:pPr indent="0" marL="0">
+            <a:pPr marL="0" indent="0">
               <a:buNone/>
             </a:pPr>
             <a:r>
@@ -11970,37 +11824,9 @@
           <a:bodyPr wrap="square" rtlCol="0" anchor="ctr"/>
           <a:lstStyle/>
           <a:p>
-            <a:pPr algn="ctr" indent="0" marL="0">
-              <a:buNone/>
-            </a:pPr>
-            <a:r>
-              <a:rPr lang="en-US" sz="1300" b="1" dirty="0">
-                <a:solidFill>
-                  <a:srgbClr val="FFFFFF"/>
-                </a:solidFill>
-                <a:latin typeface="Yu Gothic" pitchFamily="34" charset="0"/>
-                <a:ea typeface="Yu Gothic" pitchFamily="34" charset="-122"/>
-                <a:cs typeface="Yu Gothic" pitchFamily="34" charset="-120"/>
-              </a:rPr>
-              <a:t>「何をしたいか」を伝えるだけで、</a:t>
-            </a:r>
-            <a:endParaRPr lang="en-US" sz="1300" dirty="0"/>
-          </a:p>
-          <a:p>
-            <a:pPr algn="ctr" indent="0" marL="0">
-              <a:buNone/>
-            </a:pPr>
-            <a:r>
-              <a:rPr lang="en-US" sz="1300" b="1" dirty="0">
-                <a:solidFill>
-                  <a:srgbClr val="FFFFFF"/>
-                </a:solidFill>
-                <a:latin typeface="Yu Gothic" pitchFamily="34" charset="0"/>
-                <a:ea typeface="Yu Gothic" pitchFamily="34" charset="-122"/>
-                <a:cs typeface="Yu Gothic" pitchFamily="34" charset="-120"/>
-              </a:rPr>
-              <a:t>手順はClaudeが考えて実行する</a:t>
-            </a:r>
+            <a:pPr marL="0" indent="0" algn="ctr">
+              <a:buNone/>
+            </a:pPr>
             <a:endParaRPr lang="en-US" sz="1300" dirty="0"/>
           </a:p>
         </p:txBody>
@@ -12026,7 +11852,7 @@
           <a:bodyPr wrap="square" rtlCol="0" anchor="ctr"/>
           <a:lstStyle/>
           <a:p>
-            <a:pPr algn="ctr" indent="0" marL="0">
+            <a:pPr marL="0" indent="0" algn="ctr">
               <a:buNone/>
             </a:pPr>
             <a:r>
@@ -12060,6 +11886,7 @@
         <a:solidFill>
           <a:srgbClr val="FAF8F5"/>
         </a:solidFill>
+        <a:effectLst/>
       </p:bgPr>
     </p:bg>
     <p:spTree>
@@ -12122,7 +11949,7 @@
           <a:bodyPr wrap="square" rtlCol="0" anchor="ctr"/>
           <a:lstStyle/>
           <a:p>
-            <a:pPr indent="0" marL="0">
+            <a:pPr marL="0" indent="0">
               <a:buNone/>
             </a:pPr>
             <a:r>
@@ -12186,7 +12013,7 @@
           <a:bodyPr wrap="square" rtlCol="0" anchor="ctr"/>
           <a:lstStyle/>
           <a:p>
-            <a:pPr indent="0" marL="0">
+            <a:pPr marL="0" indent="0">
               <a:buNone/>
             </a:pPr>
             <a:r>
@@ -12250,7 +12077,7 @@
           <a:bodyPr wrap="square" rtlCol="0" anchor="ctr"/>
           <a:lstStyle/>
           <a:p>
-            <a:pPr algn="ctr" indent="0" marL="0">
+            <a:pPr marL="0" indent="0" algn="ctr">
               <a:buNone/>
             </a:pPr>
             <a:r>
@@ -12289,7 +12116,7 @@
           <a:bodyPr wrap="square" rtlCol="0" anchor="ctr"/>
           <a:lstStyle/>
           <a:p>
-            <a:pPr algn="ctr" indent="0" marL="0">
+            <a:pPr marL="0" indent="0" algn="ctr">
               <a:buNone/>
             </a:pPr>
             <a:r>
@@ -12328,7 +12155,7 @@
           <a:bodyPr wrap="square" rtlCol="0" anchor="ctr"/>
           <a:lstStyle/>
           <a:p>
-            <a:pPr algn="ctr" indent="0" marL="0">
+            <a:pPr marL="0" indent="0" algn="ctr">
               <a:buNone/>
             </a:pPr>
             <a:r>
@@ -12367,7 +12194,7 @@
           <a:bodyPr wrap="square" rtlCol="0" anchor="ctr"/>
           <a:lstStyle/>
           <a:p>
-            <a:pPr algn="ctr" indent="0" marL="0">
+            <a:pPr marL="0" indent="0" algn="ctr">
               <a:buNone/>
             </a:pPr>
             <a:r>
@@ -12384,7 +12211,7 @@
             <a:endParaRPr lang="en-US" sz="1200" dirty="0"/>
           </a:p>
           <a:p>
-            <a:pPr algn="ctr" indent="0" marL="0">
+            <a:pPr marL="0" indent="0" algn="ctr">
               <a:buNone/>
             </a:pPr>
             <a:r>
@@ -12423,7 +12250,7 @@
           <a:bodyPr wrap="square" rtlCol="0" anchor="ctr"/>
           <a:lstStyle/>
           <a:p>
-            <a:pPr algn="ctr" indent="0" marL="0">
+            <a:pPr marL="0" indent="0" algn="ctr">
               <a:buNone/>
             </a:pPr>
             <a:r>
@@ -12484,7 +12311,7 @@
           <a:bodyPr wrap="square" rtlCol="0" anchor="ctr"/>
           <a:lstStyle/>
           <a:p>
-            <a:pPr algn="ctr" indent="0" marL="0">
+            <a:pPr marL="0" indent="0" algn="ctr">
               <a:buNone/>
             </a:pPr>
             <a:r>
@@ -12523,7 +12350,7 @@
           <a:bodyPr wrap="square" rtlCol="0" anchor="ctr"/>
           <a:lstStyle/>
           <a:p>
-            <a:pPr algn="ctr" indent="0" marL="0">
+            <a:pPr marL="0" indent="0" algn="ctr">
               <a:buNone/>
             </a:pPr>
             <a:r>
@@ -12562,7 +12389,7 @@
           <a:bodyPr wrap="square" rtlCol="0" anchor="ctr"/>
           <a:lstStyle/>
           <a:p>
-            <a:pPr algn="ctr" indent="0" marL="0">
+            <a:pPr marL="0" indent="0" algn="ctr">
               <a:buNone/>
             </a:pPr>
             <a:r>
@@ -12601,7 +12428,7 @@
           <a:bodyPr wrap="square" rtlCol="0" anchor="ctr"/>
           <a:lstStyle/>
           <a:p>
-            <a:pPr algn="ctr" indent="0" marL="0">
+            <a:pPr marL="0" indent="0" algn="ctr">
               <a:buNone/>
             </a:pPr>
             <a:r>
@@ -12618,7 +12445,7 @@
             <a:endParaRPr lang="en-US" sz="1200" dirty="0"/>
           </a:p>
           <a:p>
-            <a:pPr algn="ctr" indent="0" marL="0">
+            <a:pPr marL="0" indent="0" algn="ctr">
               <a:buNone/>
             </a:pPr>
             <a:r>
@@ -12657,7 +12484,7 @@
           <a:bodyPr wrap="square" rtlCol="0" anchor="ctr"/>
           <a:lstStyle/>
           <a:p>
-            <a:pPr algn="ctr" indent="0" marL="0">
+            <a:pPr marL="0" indent="0" algn="ctr">
               <a:buNone/>
             </a:pPr>
             <a:r>
@@ -12718,7 +12545,7 @@
           <a:bodyPr wrap="square" rtlCol="0" anchor="ctr"/>
           <a:lstStyle/>
           <a:p>
-            <a:pPr algn="ctr" indent="0" marL="0">
+            <a:pPr marL="0" indent="0" algn="ctr">
               <a:buNone/>
             </a:pPr>
             <a:r>
@@ -12757,7 +12584,7 @@
           <a:bodyPr wrap="square" rtlCol="0" anchor="ctr"/>
           <a:lstStyle/>
           <a:p>
-            <a:pPr algn="ctr" indent="0" marL="0">
+            <a:pPr marL="0" indent="0" algn="ctr">
               <a:buNone/>
             </a:pPr>
             <a:r>
@@ -12796,7 +12623,7 @@
           <a:bodyPr wrap="square" rtlCol="0" anchor="ctr"/>
           <a:lstStyle/>
           <a:p>
-            <a:pPr algn="ctr" indent="0" marL="0">
+            <a:pPr marL="0" indent="0" algn="ctr">
               <a:buNone/>
             </a:pPr>
             <a:r>
@@ -12835,7 +12662,7 @@
           <a:bodyPr wrap="square" rtlCol="0" anchor="ctr"/>
           <a:lstStyle/>
           <a:p>
-            <a:pPr algn="ctr" indent="0" marL="0">
+            <a:pPr marL="0" indent="0" algn="ctr">
               <a:buNone/>
             </a:pPr>
             <a:r>
@@ -12852,7 +12679,7 @@
             <a:endParaRPr lang="en-US" sz="1200" dirty="0"/>
           </a:p>
           <a:p>
-            <a:pPr algn="ctr" indent="0" marL="0">
+            <a:pPr marL="0" indent="0" algn="ctr">
               <a:buNone/>
             </a:pPr>
             <a:r>
@@ -12891,7 +12718,7 @@
           <a:bodyPr wrap="square" rtlCol="0" anchor="ctr"/>
           <a:lstStyle/>
           <a:p>
-            <a:pPr algn="ctr" indent="0" marL="0">
+            <a:pPr marL="0" indent="0" algn="ctr">
               <a:buNone/>
             </a:pPr>
             <a:r>
@@ -12925,6 +12752,7 @@
         <a:solidFill>
           <a:srgbClr val="FAF8F5"/>
         </a:solidFill>
+        <a:effectLst/>
       </p:bgPr>
     </p:bg>
     <p:spTree>
@@ -12987,7 +12815,7 @@
           <a:bodyPr wrap="square" rtlCol="0" anchor="ctr"/>
           <a:lstStyle/>
           <a:p>
-            <a:pPr indent="0" marL="0">
+            <a:pPr marL="0" indent="0">
               <a:buNone/>
             </a:pPr>
             <a:r>
@@ -13076,7 +12904,7 @@
           <a:bodyPr wrap="square" rtlCol="0" anchor="ctr"/>
           <a:lstStyle/>
           <a:p>
-            <a:pPr algn="ctr" indent="0" marL="0">
+            <a:pPr marL="0" indent="0" algn="ctr">
               <a:buNone/>
             </a:pPr>
             <a:r>
@@ -13115,7 +12943,7 @@
           <a:bodyPr wrap="square" rtlCol="0" anchor="ctr"/>
           <a:lstStyle/>
           <a:p>
-            <a:pPr indent="0" marL="0">
+            <a:pPr marL="0" indent="0">
               <a:buNone/>
             </a:pPr>
             <a:r>
@@ -13154,7 +12982,7 @@
           <a:bodyPr wrap="square" rtlCol="0" anchor="ctr"/>
           <a:lstStyle/>
           <a:p>
-            <a:pPr indent="0" marL="0">
+            <a:pPr marL="0" indent="0">
               <a:buNone/>
             </a:pPr>
             <a:r>
@@ -13171,7 +12999,7 @@
             <a:endParaRPr lang="en-US" sz="1200" dirty="0"/>
           </a:p>
           <a:p>
-            <a:pPr indent="0" marL="0">
+            <a:pPr marL="0" indent="0">
               <a:buNone/>
             </a:pPr>
             <a:r>
@@ -13235,7 +13063,7 @@
           <a:bodyPr wrap="square" rtlCol="0" anchor="ctr"/>
           <a:lstStyle/>
           <a:p>
-            <a:pPr algn="ctr" indent="0" marL="0">
+            <a:pPr marL="0" indent="0" algn="ctr">
               <a:buNone/>
             </a:pPr>
             <a:r>
@@ -13274,7 +13102,7 @@
           <a:bodyPr wrap="square" rtlCol="0" anchor="ctr"/>
           <a:lstStyle/>
           <a:p>
-            <a:pPr indent="0" marL="0">
+            <a:pPr marL="0" indent="0">
               <a:buNone/>
             </a:pPr>
             <a:r>
@@ -13313,7 +13141,7 @@
           <a:bodyPr wrap="square" rtlCol="0" anchor="ctr"/>
           <a:lstStyle/>
           <a:p>
-            <a:pPr indent="0" marL="0">
+            <a:pPr marL="0" indent="0">
               <a:buNone/>
             </a:pPr>
             <a:r>
@@ -13330,7 +13158,7 @@
             <a:endParaRPr lang="en-US" sz="1200" dirty="0"/>
           </a:p>
           <a:p>
-            <a:pPr indent="0" marL="0">
+            <a:pPr marL="0" indent="0">
               <a:buNone/>
             </a:pPr>
             <a:r>
@@ -13394,7 +13222,7 @@
           <a:bodyPr wrap="square" rtlCol="0" anchor="ctr"/>
           <a:lstStyle/>
           <a:p>
-            <a:pPr algn="ctr" indent="0" marL="0">
+            <a:pPr marL="0" indent="0" algn="ctr">
               <a:buNone/>
             </a:pPr>
             <a:r>
@@ -13433,7 +13261,7 @@
           <a:bodyPr wrap="square" rtlCol="0" anchor="ctr"/>
           <a:lstStyle/>
           <a:p>
-            <a:pPr indent="0" marL="0">
+            <a:pPr marL="0" indent="0">
               <a:buNone/>
             </a:pPr>
             <a:r>
@@ -13472,7 +13300,7 @@
           <a:bodyPr wrap="square" rtlCol="0" anchor="ctr"/>
           <a:lstStyle/>
           <a:p>
-            <a:pPr indent="0" marL="0">
+            <a:pPr marL="0" indent="0">
               <a:buNone/>
             </a:pPr>
             <a:r>
@@ -13489,7 +13317,7 @@
             <a:endParaRPr lang="en-US" sz="1200" dirty="0"/>
           </a:p>
           <a:p>
-            <a:pPr indent="0" marL="0">
+            <a:pPr marL="0" indent="0">
               <a:buNone/>
             </a:pPr>
             <a:r>
@@ -13553,7 +13381,7 @@
           <a:bodyPr wrap="square" rtlCol="0" anchor="ctr"/>
           <a:lstStyle/>
           <a:p>
-            <a:pPr algn="ctr" indent="0" marL="0">
+            <a:pPr marL="0" indent="0" algn="ctr">
               <a:buNone/>
             </a:pPr>
             <a:r>
@@ -13592,7 +13420,7 @@
           <a:bodyPr wrap="square" rtlCol="0" anchor="ctr"/>
           <a:lstStyle/>
           <a:p>
-            <a:pPr algn="ctr" indent="0" marL="0">
+            <a:pPr marL="0" indent="0" algn="ctr">
               <a:buNone/>
             </a:pPr>
             <a:r>
@@ -13626,6 +13454,7 @@
         <a:solidFill>
           <a:srgbClr val="FAF8F5"/>
         </a:solidFill>
+        <a:effectLst/>
       </p:bgPr>
     </p:bg>
     <p:spTree>
@@ -13688,7 +13517,7 @@
           <a:bodyPr wrap="square" rtlCol="0" anchor="ctr"/>
           <a:lstStyle/>
           <a:p>
-            <a:pPr indent="0" marL="0">
+            <a:pPr marL="0" indent="0">
               <a:buNone/>
             </a:pPr>
             <a:r>
@@ -13752,7 +13581,7 @@
           <a:bodyPr wrap="square" rtlCol="0" anchor="ctr"/>
           <a:lstStyle/>
           <a:p>
-            <a:pPr indent="0" marL="0">
+            <a:pPr marL="0" indent="0">
               <a:buNone/>
             </a:pPr>
             <a:r>
@@ -13816,7 +13645,7 @@
           <a:bodyPr wrap="square" rtlCol="0" anchor="ctr"/>
           <a:lstStyle/>
           <a:p>
-            <a:pPr indent="0" marL="0">
+            <a:pPr marL="0" indent="0">
               <a:buNone/>
             </a:pPr>
             <a:r>
@@ -13833,7 +13662,7 @@
             <a:endParaRPr lang="en-US" sz="1100" dirty="0"/>
           </a:p>
           <a:p>
-            <a:pPr indent="0" marL="0">
+            <a:pPr marL="0" indent="0">
               <a:buNone/>
             </a:pPr>
             <a:r>
@@ -13850,7 +13679,7 @@
             <a:endParaRPr lang="en-US" sz="1100" dirty="0"/>
           </a:p>
           <a:p>
-            <a:pPr indent="0" marL="0">
+            <a:pPr marL="0" indent="0">
               <a:buNone/>
             </a:pPr>
             <a:r>
@@ -13867,7 +13696,7 @@
             <a:endParaRPr lang="en-US" sz="1100" dirty="0"/>
           </a:p>
           <a:p>
-            <a:pPr indent="0" marL="0">
+            <a:pPr marL="0" indent="0">
               <a:buNone/>
             </a:pPr>
             <a:r>
@@ -13884,7 +13713,7 @@
             <a:endParaRPr lang="en-US" sz="1100" dirty="0"/>
           </a:p>
           <a:p>
-            <a:pPr indent="0" marL="0">
+            <a:pPr marL="0" indent="0">
               <a:buNone/>
             </a:pPr>
             <a:r>
@@ -13901,7 +13730,7 @@
             <a:endParaRPr lang="en-US" sz="1100" dirty="0"/>
           </a:p>
           <a:p>
-            <a:pPr indent="0" marL="0">
+            <a:pPr marL="0" indent="0">
               <a:buNone/>
             </a:pPr>
             <a:r>
@@ -13965,7 +13794,7 @@
           <a:bodyPr wrap="square" rtlCol="0" anchor="ctr"/>
           <a:lstStyle/>
           <a:p>
-            <a:pPr indent="0" marL="0">
+            <a:pPr marL="0" indent="0">
               <a:buNone/>
             </a:pPr>
             <a:r>
@@ -14004,7 +13833,7 @@
           <a:bodyPr wrap="square" rtlCol="0" anchor="ctr"/>
           <a:lstStyle/>
           <a:p>
-            <a:pPr indent="0" marL="0">
+            <a:pPr marL="0" indent="0">
               <a:buNone/>
             </a:pPr>
             <a:r>
@@ -14043,7 +13872,7 @@
           <a:bodyPr wrap="square" rtlCol="0" anchor="ctr"/>
           <a:lstStyle/>
           <a:p>
-            <a:pPr indent="0" marL="0">
+            <a:pPr marL="0" indent="0">
               <a:buNone/>
             </a:pPr>
             <a:r>
@@ -14107,7 +13936,7 @@
           <a:bodyPr wrap="square" rtlCol="0" anchor="ctr"/>
           <a:lstStyle/>
           <a:p>
-            <a:pPr indent="0" marL="0">
+            <a:pPr marL="0" indent="0">
               <a:buNone/>
             </a:pPr>
             <a:r>
@@ -14146,7 +13975,7 @@
           <a:bodyPr wrap="square" rtlCol="0" anchor="ctr"/>
           <a:lstStyle/>
           <a:p>
-            <a:pPr indent="0" marL="0">
+            <a:pPr marL="0" indent="0">
               <a:buNone/>
             </a:pPr>
             <a:r>
@@ -14185,7 +14014,7 @@
           <a:bodyPr wrap="square" rtlCol="0" anchor="ctr"/>
           <a:lstStyle/>
           <a:p>
-            <a:pPr indent="0" marL="0">
+            <a:pPr marL="0" indent="0">
               <a:buNone/>
             </a:pPr>
             <a:r>
@@ -14224,7 +14053,7 @@
           <a:bodyPr wrap="square" rtlCol="0" anchor="ctr"/>
           <a:lstStyle/>
           <a:p>
-            <a:pPr indent="0" marL="0">
+            <a:pPr marL="0" indent="0">
               <a:buNone/>
             </a:pPr>
             <a:r>
@@ -14258,6 +14087,7 @@
         <a:solidFill>
           <a:srgbClr val="FAF8F5"/>
         </a:solidFill>
+        <a:effectLst/>
       </p:bgPr>
     </p:bg>
     <p:spTree>
@@ -14320,7 +14150,7 @@
           <a:bodyPr wrap="square" rtlCol="0" anchor="ctr"/>
           <a:lstStyle/>
           <a:p>
-            <a:pPr indent="0" marL="0">
+            <a:pPr marL="0" indent="0">
               <a:buNone/>
             </a:pPr>
             <a:r>
@@ -14384,7 +14214,7 @@
           <a:bodyPr wrap="square" rtlCol="0" anchor="ctr"/>
           <a:lstStyle/>
           <a:p>
-            <a:pPr indent="0" marL="0">
+            <a:pPr marL="0" indent="0">
               <a:buNone/>
             </a:pPr>
             <a:r>
@@ -14448,7 +14278,7 @@
           <a:bodyPr wrap="square" rtlCol="0" anchor="ctr"/>
           <a:lstStyle/>
           <a:p>
-            <a:pPr indent="0" marL="0">
+            <a:pPr marL="0" indent="0">
               <a:buNone/>
             </a:pPr>
             <a:r>
@@ -14487,7 +14317,7 @@
           <a:bodyPr wrap="square" rtlCol="0" anchor="ctr"/>
           <a:lstStyle/>
           <a:p>
-            <a:pPr indent="0" marL="0">
+            <a:pPr marL="0" indent="0">
               <a:buNone/>
             </a:pPr>
             <a:r>
@@ -14526,7 +14356,7 @@
           <a:bodyPr wrap="square" rtlCol="0" anchor="ctr"/>
           <a:lstStyle/>
           <a:p>
-            <a:pPr indent="0" marL="0">
+            <a:pPr marL="0" indent="0">
               <a:buNone/>
             </a:pPr>
             <a:r>
@@ -14565,7 +14395,7 @@
           <a:bodyPr wrap="square" rtlCol="0" anchor="ctr"/>
           <a:lstStyle/>
           <a:p>
-            <a:pPr indent="0" marL="0">
+            <a:pPr marL="0" indent="0">
               <a:buNone/>
             </a:pPr>
             <a:r>
@@ -14604,7 +14434,7 @@
           <a:bodyPr wrap="square" rtlCol="0" anchor="ctr"/>
           <a:lstStyle/>
           <a:p>
-            <a:pPr indent="0" marL="0">
+            <a:pPr marL="0" indent="0">
               <a:buNone/>
             </a:pPr>
             <a:r>
@@ -14643,7 +14473,7 @@
           <a:bodyPr wrap="square" rtlCol="0" anchor="ctr"/>
           <a:lstStyle/>
           <a:p>
-            <a:pPr indent="0" marL="0">
+            <a:pPr marL="0" indent="0">
               <a:buNone/>
             </a:pPr>
             <a:r>
@@ -14682,7 +14512,7 @@
           <a:bodyPr wrap="square" rtlCol="0" anchor="ctr"/>
           <a:lstStyle/>
           <a:p>
-            <a:pPr indent="0" marL="0">
+            <a:pPr marL="0" indent="0">
               <a:buNone/>
             </a:pPr>
             <a:r>
@@ -14721,7 +14551,7 @@
           <a:bodyPr wrap="square" rtlCol="0" anchor="ctr"/>
           <a:lstStyle/>
           <a:p>
-            <a:pPr indent="0" marL="0">
+            <a:pPr marL="0" indent="0">
               <a:buNone/>
             </a:pPr>
             <a:r>
@@ -14760,7 +14590,7 @@
           <a:bodyPr wrap="square" rtlCol="0" anchor="ctr"/>
           <a:lstStyle/>
           <a:p>
-            <a:pPr indent="0" marL="0">
+            <a:pPr marL="0" indent="0">
               <a:buNone/>
             </a:pPr>
             <a:r>
@@ -14799,7 +14629,7 @@
           <a:bodyPr wrap="square" rtlCol="0" anchor="ctr"/>
           <a:lstStyle/>
           <a:p>
-            <a:pPr indent="0" marL="0">
+            <a:pPr marL="0" indent="0">
               <a:buNone/>
             </a:pPr>
             <a:r>
@@ -14863,7 +14693,7 @@
           <a:bodyPr wrap="square" rtlCol="0" anchor="ctr"/>
           <a:lstStyle/>
           <a:p>
-            <a:pPr algn="ctr" indent="0" marL="0">
+            <a:pPr marL="0" indent="0" algn="ctr">
               <a:buNone/>
             </a:pPr>
             <a:r>
@@ -14897,6 +14727,7 @@
         <a:solidFill>
           <a:srgbClr val="FAF8F5"/>
         </a:solidFill>
+        <a:effectLst/>
       </p:bgPr>
     </p:bg>
     <p:spTree>
@@ -14959,7 +14790,7 @@
           <a:bodyPr wrap="square" rtlCol="0" anchor="ctr"/>
           <a:lstStyle/>
           <a:p>
-            <a:pPr indent="0" marL="0">
+            <a:pPr marL="0" indent="0">
               <a:buNone/>
             </a:pPr>
             <a:r>
@@ -15023,7 +14854,7 @@
           <a:bodyPr wrap="square" rtlCol="0" anchor="ctr"/>
           <a:lstStyle/>
           <a:p>
-            <a:pPr indent="0" marL="0">
+            <a:pPr marL="0" indent="0">
               <a:buNone/>
             </a:pPr>
             <a:r>
@@ -15087,7 +14918,7 @@
           <a:bodyPr wrap="square" rtlCol="0" anchor="ctr"/>
           <a:lstStyle/>
           <a:p>
-            <a:pPr indent="0" marL="0">
+            <a:pPr marL="0" indent="0">
               <a:buNone/>
             </a:pPr>
             <a:r>
@@ -15104,7 +14935,7 @@
             <a:endParaRPr lang="en-US" sz="1100" dirty="0"/>
           </a:p>
           <a:p>
-            <a:pPr indent="0" marL="0">
+            <a:pPr marL="0" indent="0">
               <a:buNone/>
             </a:pPr>
             <a:r>
@@ -15143,7 +14974,7 @@
           <a:bodyPr wrap="square" rtlCol="0" anchor="ctr"/>
           <a:lstStyle/>
           <a:p>
-            <a:pPr indent="0" marL="0">
+            <a:pPr marL="0" indent="0">
               <a:buNone/>
             </a:pPr>
             <a:r>
@@ -15207,7 +15038,7 @@
           <a:bodyPr wrap="square" rtlCol="0" anchor="ctr"/>
           <a:lstStyle/>
           <a:p>
-            <a:pPr algn="ctr" indent="0" marL="0">
+            <a:pPr marL="0" indent="0" algn="ctr">
               <a:buNone/>
             </a:pPr>
             <a:r>
@@ -15246,7 +15077,7 @@
           <a:bodyPr wrap="square" rtlCol="0" anchor="ctr"/>
           <a:lstStyle/>
           <a:p>
-            <a:pPr indent="0" marL="0">
+            <a:pPr marL="0" indent="0">
               <a:buNone/>
             </a:pPr>
             <a:r>
@@ -15310,7 +15141,7 @@
           <a:bodyPr wrap="square" rtlCol="0" anchor="ctr"/>
           <a:lstStyle/>
           <a:p>
-            <a:pPr algn="ctr" indent="0" marL="0">
+            <a:pPr marL="0" indent="0" algn="ctr">
               <a:buNone/>
             </a:pPr>
             <a:r>
@@ -15349,7 +15180,7 @@
           <a:bodyPr wrap="square" rtlCol="0" anchor="ctr"/>
           <a:lstStyle/>
           <a:p>
-            <a:pPr indent="0" marL="0">
+            <a:pPr marL="0" indent="0">
               <a:buNone/>
             </a:pPr>
             <a:r>
@@ -15413,7 +15244,7 @@
           <a:bodyPr wrap="square" rtlCol="0" anchor="ctr"/>
           <a:lstStyle/>
           <a:p>
-            <a:pPr algn="ctr" indent="0" marL="0">
+            <a:pPr marL="0" indent="0" algn="ctr">
               <a:buNone/>
             </a:pPr>
             <a:r>
@@ -15452,7 +15283,7 @@
           <a:bodyPr wrap="square" rtlCol="0" anchor="ctr"/>
           <a:lstStyle/>
           <a:p>
-            <a:pPr indent="0" marL="0">
+            <a:pPr marL="0" indent="0">
               <a:buNone/>
             </a:pPr>
             <a:r>
@@ -15516,7 +15347,7 @@
           <a:bodyPr wrap="square" rtlCol="0" anchor="ctr"/>
           <a:lstStyle/>
           <a:p>
-            <a:pPr algn="ctr" indent="0" marL="0">
+            <a:pPr marL="0" indent="0" algn="ctr">
               <a:buNone/>
             </a:pPr>
             <a:r>
@@ -15555,7 +15386,7 @@
           <a:bodyPr wrap="square" rtlCol="0" anchor="ctr"/>
           <a:lstStyle/>
           <a:p>
-            <a:pPr indent="0" marL="0">
+            <a:pPr marL="0" indent="0">
               <a:buNone/>
             </a:pPr>
             <a:r>
@@ -15619,7 +15450,7 @@
           <a:bodyPr wrap="square" rtlCol="0" anchor="ctr"/>
           <a:lstStyle/>
           <a:p>
-            <a:pPr algn="ctr" indent="0" marL="0">
+            <a:pPr marL="0" indent="0" algn="ctr">
               <a:buNone/>
             </a:pPr>
             <a:r>
@@ -15653,6 +15484,7 @@
         <a:solidFill>
           <a:srgbClr val="FAF8F5"/>
         </a:solidFill>
+        <a:effectLst/>
       </p:bgPr>
     </p:bg>
     <p:spTree>
@@ -15715,7 +15547,7 @@
           <a:bodyPr wrap="square" rtlCol="0" anchor="ctr"/>
           <a:lstStyle/>
           <a:p>
-            <a:pPr indent="0" marL="0">
+            <a:pPr marL="0" indent="0">
               <a:buNone/>
             </a:pPr>
             <a:r>
@@ -15779,7 +15611,7 @@
           <a:bodyPr wrap="square" rtlCol="0" anchor="ctr"/>
           <a:lstStyle/>
           <a:p>
-            <a:pPr indent="0" marL="0">
+            <a:pPr marL="0" indent="0">
               <a:buNone/>
             </a:pPr>
             <a:r>
@@ -15868,7 +15700,7 @@
           <a:bodyPr wrap="square" rtlCol="0" anchor="ctr"/>
           <a:lstStyle/>
           <a:p>
-            <a:pPr algn="ctr" indent="0" marL="0">
+            <a:pPr marL="0" indent="0" algn="ctr">
               <a:buNone/>
             </a:pPr>
             <a:r>
@@ -15907,7 +15739,7 @@
           <a:bodyPr wrap="square" rtlCol="0" anchor="ctr"/>
           <a:lstStyle/>
           <a:p>
-            <a:pPr algn="ctr" indent="0" marL="0">
+            <a:pPr marL="0" indent="0" algn="ctr">
               <a:buNone/>
             </a:pPr>
             <a:r>
@@ -15946,7 +15778,7 @@
           <a:bodyPr wrap="square" rtlCol="0" anchor="ctr"/>
           <a:lstStyle/>
           <a:p>
-            <a:pPr algn="ctr" indent="0" marL="0">
+            <a:pPr marL="0" indent="0" algn="ctr">
               <a:buNone/>
             </a:pPr>
             <a:r>
@@ -15963,7 +15795,7 @@
             <a:endParaRPr lang="en-US" sz="1100" dirty="0"/>
           </a:p>
           <a:p>
-            <a:pPr algn="ctr" indent="0" marL="0">
+            <a:pPr marL="0" indent="0" algn="ctr">
               <a:buNone/>
             </a:pPr>
             <a:r>
@@ -16002,7 +15834,7 @@
           <a:bodyPr wrap="square" rtlCol="0" anchor="ctr"/>
           <a:lstStyle/>
           <a:p>
-            <a:pPr algn="ctr" indent="0" marL="0">
+            <a:pPr marL="0" indent="0" algn="ctr">
               <a:buNone/>
             </a:pPr>
             <a:r>
@@ -16088,7 +15920,7 @@
           <a:bodyPr wrap="square" rtlCol="0" anchor="ctr"/>
           <a:lstStyle/>
           <a:p>
-            <a:pPr algn="ctr" indent="0" marL="0">
+            <a:pPr marL="0" indent="0" algn="ctr">
               <a:buNone/>
             </a:pPr>
             <a:r>
@@ -16127,7 +15959,7 @@
           <a:bodyPr wrap="square" rtlCol="0" anchor="ctr"/>
           <a:lstStyle/>
           <a:p>
-            <a:pPr algn="ctr" indent="0" marL="0">
+            <a:pPr marL="0" indent="0" algn="ctr">
               <a:buNone/>
             </a:pPr>
             <a:r>
@@ -16166,7 +15998,7 @@
           <a:bodyPr wrap="square" rtlCol="0" anchor="ctr"/>
           <a:lstStyle/>
           <a:p>
-            <a:pPr algn="ctr" indent="0" marL="0">
+            <a:pPr marL="0" indent="0" algn="ctr">
               <a:buNone/>
             </a:pPr>
             <a:r>
@@ -16183,7 +16015,7 @@
             <a:endParaRPr lang="en-US" sz="1100" dirty="0"/>
           </a:p>
           <a:p>
-            <a:pPr algn="ctr" indent="0" marL="0">
+            <a:pPr marL="0" indent="0" algn="ctr">
               <a:buNone/>
             </a:pPr>
             <a:r>
@@ -16222,7 +16054,7 @@
           <a:bodyPr wrap="square" rtlCol="0" anchor="ctr"/>
           <a:lstStyle/>
           <a:p>
-            <a:pPr algn="ctr" indent="0" marL="0">
+            <a:pPr marL="0" indent="0" algn="ctr">
               <a:buNone/>
             </a:pPr>
             <a:r>
@@ -16308,7 +16140,7 @@
           <a:bodyPr wrap="square" rtlCol="0" anchor="ctr"/>
           <a:lstStyle/>
           <a:p>
-            <a:pPr algn="ctr" indent="0" marL="0">
+            <a:pPr marL="0" indent="0" algn="ctr">
               <a:buNone/>
             </a:pPr>
             <a:r>
@@ -16347,7 +16179,7 @@
           <a:bodyPr wrap="square" rtlCol="0" anchor="ctr"/>
           <a:lstStyle/>
           <a:p>
-            <a:pPr algn="ctr" indent="0" marL="0">
+            <a:pPr marL="0" indent="0" algn="ctr">
               <a:buNone/>
             </a:pPr>
             <a:r>
@@ -16386,7 +16218,7 @@
           <a:bodyPr wrap="square" rtlCol="0" anchor="ctr"/>
           <a:lstStyle/>
           <a:p>
-            <a:pPr algn="ctr" indent="0" marL="0">
+            <a:pPr marL="0" indent="0" algn="ctr">
               <a:buNone/>
             </a:pPr>
             <a:r>
@@ -16403,7 +16235,7 @@
             <a:endParaRPr lang="en-US" sz="1100" dirty="0"/>
           </a:p>
           <a:p>
-            <a:pPr algn="ctr" indent="0" marL="0">
+            <a:pPr marL="0" indent="0" algn="ctr">
               <a:buNone/>
             </a:pPr>
             <a:r>
@@ -16442,7 +16274,7 @@
           <a:bodyPr wrap="square" rtlCol="0" anchor="ctr"/>
           <a:lstStyle/>
           <a:p>
-            <a:pPr algn="ctr" indent="0" marL="0">
+            <a:pPr marL="0" indent="0" algn="ctr">
               <a:buNone/>
             </a:pPr>
             <a:r>
@@ -16528,7 +16360,7 @@
           <a:bodyPr wrap="square" rtlCol="0" anchor="ctr"/>
           <a:lstStyle/>
           <a:p>
-            <a:pPr algn="ctr" indent="0" marL="0">
+            <a:pPr marL="0" indent="0" algn="ctr">
               <a:buNone/>
             </a:pPr>
             <a:r>
@@ -16567,7 +16399,7 @@
           <a:bodyPr wrap="square" rtlCol="0" anchor="ctr"/>
           <a:lstStyle/>
           <a:p>
-            <a:pPr algn="ctr" indent="0" marL="0">
+            <a:pPr marL="0" indent="0" algn="ctr">
               <a:buNone/>
             </a:pPr>
             <a:r>
@@ -16606,7 +16438,7 @@
           <a:bodyPr wrap="square" rtlCol="0" anchor="ctr"/>
           <a:lstStyle/>
           <a:p>
-            <a:pPr algn="ctr" indent="0" marL="0">
+            <a:pPr marL="0" indent="0" algn="ctr">
               <a:buNone/>
             </a:pPr>
             <a:r>
@@ -16623,7 +16455,7 @@
             <a:endParaRPr lang="en-US" sz="1100" dirty="0"/>
           </a:p>
           <a:p>
-            <a:pPr algn="ctr" indent="0" marL="0">
+            <a:pPr marL="0" indent="0" algn="ctr">
               <a:buNone/>
             </a:pPr>
             <a:r>
@@ -16662,7 +16494,7 @@
           <a:bodyPr wrap="square" rtlCol="0" anchor="ctr"/>
           <a:lstStyle/>
           <a:p>
-            <a:pPr algn="ctr" indent="0" marL="0">
+            <a:pPr marL="0" indent="0" algn="ctr">
               <a:buNone/>
             </a:pPr>
             <a:r>
@@ -16748,7 +16580,7 @@
           <a:bodyPr wrap="square" rtlCol="0" anchor="ctr"/>
           <a:lstStyle/>
           <a:p>
-            <a:pPr algn="ctr" indent="0" marL="0">
+            <a:pPr marL="0" indent="0" algn="ctr">
               <a:buNone/>
             </a:pPr>
             <a:r>
@@ -16787,7 +16619,7 @@
           <a:bodyPr wrap="square" rtlCol="0" anchor="ctr"/>
           <a:lstStyle/>
           <a:p>
-            <a:pPr algn="ctr" indent="0" marL="0">
+            <a:pPr marL="0" indent="0" algn="ctr">
               <a:buNone/>
             </a:pPr>
             <a:r>
@@ -16826,7 +16658,7 @@
           <a:bodyPr wrap="square" rtlCol="0" anchor="ctr"/>
           <a:lstStyle/>
           <a:p>
-            <a:pPr algn="ctr" indent="0" marL="0">
+            <a:pPr marL="0" indent="0" algn="ctr">
               <a:buNone/>
             </a:pPr>
             <a:r>
@@ -16843,7 +16675,7 @@
             <a:endParaRPr lang="en-US" sz="1100" dirty="0"/>
           </a:p>
           <a:p>
-            <a:pPr algn="ctr" indent="0" marL="0">
+            <a:pPr marL="0" indent="0" algn="ctr">
               <a:buNone/>
             </a:pPr>
             <a:r>
@@ -16882,7 +16714,7 @@
           <a:bodyPr wrap="square" rtlCol="0" anchor="ctr"/>
           <a:lstStyle/>
           <a:p>
-            <a:pPr indent="0" marL="0">
+            <a:pPr marL="0" indent="0">
               <a:buNone/>
             </a:pPr>
             <a:r>
@@ -16921,7 +16753,7 @@
           <a:bodyPr wrap="square" rtlCol="0" anchor="ctr"/>
           <a:lstStyle/>
           <a:p>
-            <a:pPr indent="0" marL="0">
+            <a:pPr marL="0" indent="0">
               <a:buNone/>
             </a:pPr>
             <a:r>
@@ -16955,6 +16787,7 @@
         <a:solidFill>
           <a:srgbClr val="FAF8F5"/>
         </a:solidFill>
+        <a:effectLst/>
       </p:bgPr>
     </p:bg>
     <p:spTree>
@@ -17017,7 +16850,7 @@
           <a:bodyPr wrap="square" rtlCol="0" anchor="ctr"/>
           <a:lstStyle/>
           <a:p>
-            <a:pPr indent="0" marL="0">
+            <a:pPr marL="0" indent="0">
               <a:buNone/>
             </a:pPr>
             <a:r>
@@ -17081,7 +16914,7 @@
           <a:bodyPr wrap="square" rtlCol="0" anchor="ctr"/>
           <a:lstStyle/>
           <a:p>
-            <a:pPr indent="0" marL="0">
+            <a:pPr marL="0" indent="0">
               <a:buNone/>
             </a:pPr>
             <a:r>
@@ -17145,7 +16978,7 @@
           <a:bodyPr wrap="square" rtlCol="0" anchor="ctr"/>
           <a:lstStyle/>
           <a:p>
-            <a:pPr indent="0" marL="0">
+            <a:pPr marL="0" indent="0">
               <a:buNone/>
             </a:pPr>
             <a:r>
@@ -17184,7 +17017,7 @@
           <a:bodyPr wrap="square" rtlCol="0" anchor="ctr"/>
           <a:lstStyle/>
           <a:p>
-            <a:pPr indent="0" marL="0">
+            <a:pPr marL="0" indent="0">
               <a:buNone/>
             </a:pPr>
             <a:r>
@@ -17223,7 +17056,7 @@
           <a:bodyPr wrap="square" rtlCol="0" anchor="ctr"/>
           <a:lstStyle/>
           <a:p>
-            <a:pPr indent="0" marL="0">
+            <a:pPr marL="0" indent="0">
               <a:buNone/>
             </a:pPr>
             <a:r>
@@ -17287,7 +17120,7 @@
           <a:bodyPr wrap="square" rtlCol="0" anchor="ctr"/>
           <a:lstStyle/>
           <a:p>
-            <a:pPr indent="0" marL="0">
+            <a:pPr marL="0" indent="0">
               <a:buNone/>
             </a:pPr>
             <a:r>
@@ -17304,7 +17137,7 @@
             <a:endParaRPr lang="en-US" sz="1200" dirty="0"/>
           </a:p>
           <a:p>
-            <a:pPr indent="0" marL="0">
+            <a:pPr marL="0" indent="0">
               <a:buNone/>
             </a:pPr>
             <a:r>
@@ -17343,7 +17176,7 @@
           <a:bodyPr wrap="square" rtlCol="0" anchor="ctr"/>
           <a:lstStyle/>
           <a:p>
-            <a:pPr algn="ctr" indent="0" marL="0">
+            <a:pPr marL="0" indent="0" algn="ctr">
               <a:buNone/>
             </a:pPr>
             <a:r>
@@ -17404,7 +17237,7 @@
           <a:bodyPr wrap="square" rtlCol="0" anchor="ctr"/>
           <a:lstStyle/>
           <a:p>
-            <a:pPr indent="0" marL="0">
+            <a:pPr marL="0" indent="0">
               <a:buNone/>
             </a:pPr>
             <a:r>
@@ -17421,7 +17254,7 @@
             <a:endParaRPr lang="en-US" sz="1200" dirty="0"/>
           </a:p>
           <a:p>
-            <a:pPr indent="0" marL="0">
+            <a:pPr marL="0" indent="0">
               <a:buNone/>
             </a:pPr>
             <a:r>
@@ -17485,7 +17318,7 @@
           <a:bodyPr wrap="square" rtlCol="0" anchor="ctr"/>
           <a:lstStyle/>
           <a:p>
-            <a:pPr indent="0" marL="0">
+            <a:pPr marL="0" indent="0">
               <a:buNone/>
             </a:pPr>
             <a:r>
@@ -17502,7 +17335,7 @@
             <a:endParaRPr lang="en-US" sz="1200" dirty="0"/>
           </a:p>
           <a:p>
-            <a:pPr indent="0" marL="0">
+            <a:pPr marL="0" indent="0">
               <a:buNone/>
             </a:pPr>
             <a:r>
@@ -17541,7 +17374,7 @@
           <a:bodyPr wrap="square" rtlCol="0" anchor="ctr"/>
           <a:lstStyle/>
           <a:p>
-            <a:pPr algn="ctr" indent="0" marL="0">
+            <a:pPr marL="0" indent="0" algn="ctr">
               <a:buNone/>
             </a:pPr>
             <a:r>
@@ -17602,7 +17435,7 @@
           <a:bodyPr wrap="square" rtlCol="0" anchor="ctr"/>
           <a:lstStyle/>
           <a:p>
-            <a:pPr indent="0" marL="0">
+            <a:pPr marL="0" indent="0">
               <a:buNone/>
             </a:pPr>
             <a:r>
@@ -17619,7 +17452,7 @@
             <a:endParaRPr lang="en-US" sz="1200" dirty="0"/>
           </a:p>
           <a:p>
-            <a:pPr indent="0" marL="0">
+            <a:pPr marL="0" indent="0">
               <a:buNone/>
             </a:pPr>
             <a:r>
@@ -17683,7 +17516,7 @@
           <a:bodyPr wrap="square" rtlCol="0" anchor="ctr"/>
           <a:lstStyle/>
           <a:p>
-            <a:pPr algn="ctr" indent="0" marL="0">
+            <a:pPr marL="0" indent="0" algn="ctr">
               <a:buNone/>
             </a:pPr>
             <a:r>
@@ -18002,4 +17835,299 @@
     </a:ext>
   </a:extLst>
 </a:theme>
+</file>
+
+<file path=ppt/theme/theme2.xml><?xml version="1.0" encoding="utf-8"?>
+<a:theme xmlns:a="http://schemas.openxmlformats.org/drawingml/2006/main" name="Office テーマ">
+  <a:themeElements>
+    <a:clrScheme name="Office">
+      <a:dk1>
+        <a:sysClr val="windowText" lastClr="000000"/>
+      </a:dk1>
+      <a:lt1>
+        <a:sysClr val="window" lastClr="FFFFFF"/>
+      </a:lt1>
+      <a:dk2>
+        <a:srgbClr val="44546A"/>
+      </a:dk2>
+      <a:lt2>
+        <a:srgbClr val="E7E6E6"/>
+      </a:lt2>
+      <a:accent1>
+        <a:srgbClr val="4472C4"/>
+      </a:accent1>
+      <a:accent2>
+        <a:srgbClr val="ED7D31"/>
+      </a:accent2>
+      <a:accent3>
+        <a:srgbClr val="A5A5A5"/>
+      </a:accent3>
+      <a:accent4>
+        <a:srgbClr val="FFC000"/>
+      </a:accent4>
+      <a:accent5>
+        <a:srgbClr val="5B9BD5"/>
+      </a:accent5>
+      <a:accent6>
+        <a:srgbClr val="70AD47"/>
+      </a:accent6>
+      <a:hlink>
+        <a:srgbClr val="0563C1"/>
+      </a:hlink>
+      <a:folHlink>
+        <a:srgbClr val="954F72"/>
+      </a:folHlink>
+    </a:clrScheme>
+    <a:fontScheme name="Office">
+      <a:majorFont>
+        <a:latin typeface="游ゴシック Light" panose="020F0302020204030204"/>
+        <a:ea typeface=""/>
+        <a:cs typeface=""/>
+        <a:font script="Jpan" typeface="游ゴシック Light"/>
+        <a:font script="Hang" typeface="맑은 고딕"/>
+        <a:font script="Hans" typeface="等线 Light"/>
+        <a:font script="Hant" typeface="新細明體"/>
+        <a:font script="Arab" typeface="Times New Roman"/>
+        <a:font script="Hebr" typeface="Times New Roman"/>
+        <a:font script="Thai" typeface="Angsana New"/>
+        <a:font script="Ethi" typeface="Nyala"/>
+        <a:font script="Beng" typeface="Vrinda"/>
+        <a:font script="Gujr" typeface="Shruti"/>
+        <a:font script="Khmr" typeface="MoolBoran"/>
+        <a:font script="Knda" typeface="Tunga"/>
+        <a:font script="Guru" typeface="Raavi"/>
+        <a:font script="Cans" typeface="Euphemia"/>
+        <a:font script="Cher" typeface="Plantagenet Cherokee"/>
+        <a:font script="Yiii" typeface="Microsoft Yi Baiti"/>
+        <a:font script="Tibt" typeface="Microsoft Himalaya"/>
+        <a:font script="Thaa" typeface="MV Boli"/>
+        <a:font script="Deva" typeface="Mangal"/>
+        <a:font script="Telu" typeface="Gautami"/>
+        <a:font script="Taml" typeface="Latha"/>
+        <a:font script="Syrc" typeface="Estrangelo Edessa"/>
+        <a:font script="Orya" typeface="Kalinga"/>
+        <a:font script="Mlym" typeface="Kartika"/>
+        <a:font script="Laoo" typeface="DokChampa"/>
+        <a:font script="Sinh" typeface="Iskoola Pota"/>
+        <a:font script="Mong" typeface="Mongolian Baiti"/>
+        <a:font script="Viet" typeface="Times New Roman"/>
+        <a:font script="Uigh" typeface="Microsoft Uighur"/>
+        <a:font script="Geor" typeface="Sylfaen"/>
+        <a:font script="Armn" typeface="Arial"/>
+        <a:font script="Bugi" typeface="Leelawadee UI"/>
+        <a:font script="Bopo" typeface="Microsoft JhengHei"/>
+        <a:font script="Java" typeface="Javanese Text"/>
+        <a:font script="Lisu" typeface="Segoe UI"/>
+        <a:font script="Mymr" typeface="Myanmar Text"/>
+        <a:font script="Nkoo" typeface="Ebrima"/>
+        <a:font script="Olck" typeface="Nirmala UI"/>
+        <a:font script="Osma" typeface="Ebrima"/>
+        <a:font script="Phag" typeface="Phagspa"/>
+        <a:font script="Syrn" typeface="Estrangelo Edessa"/>
+        <a:font script="Syrj" typeface="Estrangelo Edessa"/>
+        <a:font script="Syre" typeface="Estrangelo Edessa"/>
+        <a:font script="Sora" typeface="Nirmala UI"/>
+        <a:font script="Tale" typeface="Microsoft Tai Le"/>
+        <a:font script="Talu" typeface="Microsoft New Tai Lue"/>
+        <a:font script="Tfng" typeface="Ebrima"/>
+      </a:majorFont>
+      <a:minorFont>
+        <a:latin typeface="游ゴシック" panose="020F0502020204030204"/>
+        <a:ea typeface=""/>
+        <a:cs typeface=""/>
+        <a:font script="Jpan" typeface="游ゴシック"/>
+        <a:font script="Hang" typeface="맑은 고딕"/>
+        <a:font script="Hans" typeface="等线"/>
+        <a:font script="Hant" typeface="新細明體"/>
+        <a:font script="Arab" typeface="Arial"/>
+        <a:font script="Hebr" typeface="Arial"/>
+        <a:font script="Thai" typeface="Cordia New"/>
+        <a:font script="Ethi" typeface="Nyala"/>
+        <a:font script="Beng" typeface="Vrinda"/>
+        <a:font script="Gujr" typeface="Shruti"/>
+        <a:font script="Khmr" typeface="DaunPenh"/>
+        <a:font script="Knda" typeface="Tunga"/>
+        <a:font script="Guru" typeface="Raavi"/>
+        <a:font script="Cans" typeface="Euphemia"/>
+        <a:font script="Cher" typeface="Plantagenet Cherokee"/>
+        <a:font script="Yiii" typeface="Microsoft Yi Baiti"/>
+        <a:font script="Tibt" typeface="Microsoft Himalaya"/>
+        <a:font script="Thaa" typeface="MV Boli"/>
+        <a:font script="Deva" typeface="Mangal"/>
+        <a:font script="Telu" typeface="Gautami"/>
+        <a:font script="Taml" typeface="Latha"/>
+        <a:font script="Syrc" typeface="Estrangelo Edessa"/>
+        <a:font script="Orya" typeface="Kalinga"/>
+        <a:font script="Mlym" typeface="Kartika"/>
+        <a:font script="Laoo" typeface="DokChampa"/>
+        <a:font script="Sinh" typeface="Iskoola Pota"/>
+        <a:font script="Mong" typeface="Mongolian Baiti"/>
+        <a:font script="Viet" typeface="Arial"/>
+        <a:font script="Uigh" typeface="Microsoft Uighur"/>
+        <a:font script="Geor" typeface="Sylfaen"/>
+        <a:font script="Armn" typeface="Arial"/>
+        <a:font script="Bugi" typeface="Leelawadee UI"/>
+        <a:font script="Bopo" typeface="Microsoft JhengHei"/>
+        <a:font script="Java" typeface="Javanese Text"/>
+        <a:font script="Lisu" typeface="Segoe UI"/>
+        <a:font script="Mymr" typeface="Myanmar Text"/>
+        <a:font script="Nkoo" typeface="Ebrima"/>
+        <a:font script="Olck" typeface="Nirmala UI"/>
+        <a:font script="Osma" typeface="Ebrima"/>
+        <a:font script="Phag" typeface="Phagspa"/>
+        <a:font script="Syrn" typeface="Estrangelo Edessa"/>
+        <a:font script="Syrj" typeface="Estrangelo Edessa"/>
+        <a:font script="Syre" typeface="Estrangelo Edessa"/>
+        <a:font script="Sora" typeface="Nirmala UI"/>
+        <a:font script="Tale" typeface="Microsoft Tai Le"/>
+        <a:font script="Talu" typeface="Microsoft New Tai Lue"/>
+        <a:font script="Tfng" typeface="Ebrima"/>
+      </a:minorFont>
+    </a:fontScheme>
+    <a:fmtScheme name="Office">
+      <a:fillStyleLst>
+        <a:solidFill>
+          <a:schemeClr val="phClr"/>
+        </a:solidFill>
+        <a:gradFill rotWithShape="1">
+          <a:gsLst>
+            <a:gs pos="0">
+              <a:schemeClr val="phClr">
+                <a:lumMod val="110000"/>
+                <a:satMod val="105000"/>
+                <a:tint val="67000"/>
+              </a:schemeClr>
+            </a:gs>
+            <a:gs pos="50000">
+              <a:schemeClr val="phClr">
+                <a:lumMod val="105000"/>
+                <a:satMod val="103000"/>
+                <a:tint val="73000"/>
+              </a:schemeClr>
+            </a:gs>
+            <a:gs pos="100000">
+              <a:schemeClr val="phClr">
+                <a:lumMod val="105000"/>
+                <a:satMod val="109000"/>
+                <a:tint val="81000"/>
+              </a:schemeClr>
+            </a:gs>
+          </a:gsLst>
+          <a:lin ang="5400000" scaled="0"/>
+        </a:gradFill>
+        <a:gradFill rotWithShape="1">
+          <a:gsLst>
+            <a:gs pos="0">
+              <a:schemeClr val="phClr">
+                <a:satMod val="103000"/>
+                <a:lumMod val="102000"/>
+                <a:tint val="94000"/>
+              </a:schemeClr>
+            </a:gs>
+            <a:gs pos="50000">
+              <a:schemeClr val="phClr">
+                <a:satMod val="110000"/>
+                <a:lumMod val="100000"/>
+                <a:shade val="100000"/>
+              </a:schemeClr>
+            </a:gs>
+            <a:gs pos="100000">
+              <a:schemeClr val="phClr">
+                <a:lumMod val="99000"/>
+                <a:satMod val="120000"/>
+                <a:shade val="78000"/>
+              </a:schemeClr>
+            </a:gs>
+          </a:gsLst>
+          <a:lin ang="5400000" scaled="0"/>
+        </a:gradFill>
+      </a:fillStyleLst>
+      <a:lnStyleLst>
+        <a:ln w="6350" cap="flat" cmpd="sng" algn="ctr">
+          <a:solidFill>
+            <a:schemeClr val="phClr"/>
+          </a:solidFill>
+          <a:prstDash val="solid"/>
+          <a:miter lim="800000"/>
+        </a:ln>
+        <a:ln w="12700" cap="flat" cmpd="sng" algn="ctr">
+          <a:solidFill>
+            <a:schemeClr val="phClr"/>
+          </a:solidFill>
+          <a:prstDash val="solid"/>
+          <a:miter lim="800000"/>
+        </a:ln>
+        <a:ln w="19050" cap="flat" cmpd="sng" algn="ctr">
+          <a:solidFill>
+            <a:schemeClr val="phClr"/>
+          </a:solidFill>
+          <a:prstDash val="solid"/>
+          <a:miter lim="800000"/>
+        </a:ln>
+      </a:lnStyleLst>
+      <a:effectStyleLst>
+        <a:effectStyle>
+          <a:effectLst/>
+        </a:effectStyle>
+        <a:effectStyle>
+          <a:effectLst/>
+        </a:effectStyle>
+        <a:effectStyle>
+          <a:effectLst>
+            <a:outerShdw blurRad="57150" dist="19050" dir="5400000" algn="ctr" rotWithShape="0">
+              <a:srgbClr val="000000">
+                <a:alpha val="63000"/>
+              </a:srgbClr>
+            </a:outerShdw>
+          </a:effectLst>
+        </a:effectStyle>
+      </a:effectStyleLst>
+      <a:bgFillStyleLst>
+        <a:solidFill>
+          <a:schemeClr val="phClr"/>
+        </a:solidFill>
+        <a:solidFill>
+          <a:schemeClr val="phClr">
+            <a:tint val="95000"/>
+            <a:satMod val="170000"/>
+          </a:schemeClr>
+        </a:solidFill>
+        <a:gradFill rotWithShape="1">
+          <a:gsLst>
+            <a:gs pos="0">
+              <a:schemeClr val="phClr">
+                <a:tint val="93000"/>
+                <a:satMod val="150000"/>
+                <a:shade val="98000"/>
+                <a:lumMod val="102000"/>
+              </a:schemeClr>
+            </a:gs>
+            <a:gs pos="50000">
+              <a:schemeClr val="phClr">
+                <a:tint val="98000"/>
+                <a:satMod val="130000"/>
+                <a:shade val="90000"/>
+                <a:lumMod val="103000"/>
+              </a:schemeClr>
+            </a:gs>
+            <a:gs pos="100000">
+              <a:schemeClr val="phClr">
+                <a:shade val="63000"/>
+                <a:satMod val="120000"/>
+              </a:schemeClr>
+            </a:gs>
+          </a:gsLst>
+          <a:lin ang="5400000" scaled="0"/>
+        </a:gradFill>
+      </a:bgFillStyleLst>
+    </a:fmtScheme>
+  </a:themeElements>
+  <a:objectDefaults/>
+  <a:extraClrSchemeLst/>
+  <a:extLst>
+    <a:ext uri="{05A4C25C-085E-4340-85A3-A5531E510DB2}">
+      <thm15:themeFamily xmlns:thm15="http://schemas.microsoft.com/office/thememl/2012/main" name="Office Theme" id="{62F939B6-93AF-4DB8-9C6B-D6C7DFDC589F}" vid="{4A3C46E8-61CC-4603-A589-7422A47A8E4A}"/>
+    </a:ext>
+  </a:extLst>
+</a:theme>
 </file>
</xml_diff>

<commit_message>
Update PPT: manual edits to ClaudeCode_ShinesoftIntro.pptx
Co-Authored-By: Claude Sonnet 4.6 <noreply@anthropic.com>
</commit_message>
<xml_diff>
--- a/ClaudeCode_ShinesoftIntro.pptx
+++ b/ClaudeCode_ShinesoftIntro.pptx
@@ -5287,8 +5287,8 @@
         </p:nvSpPr>
         <p:spPr>
           <a:xfrm>
-            <a:off x="365760" y="4526280"/>
-            <a:ext cx="11338560" cy="594360"/>
+            <a:off x="365760" y="4683760"/>
+            <a:ext cx="11338560" cy="673100"/>
           </a:xfrm>
           <a:prstGeom prst="rect">
             <a:avLst/>
@@ -5312,24 +5312,68 @@
         </p:nvSpPr>
         <p:spPr>
           <a:xfrm>
-            <a:off x="365760" y="4526280"/>
-            <a:ext cx="11338560" cy="594360"/>
-          </a:xfrm>
-          <a:prstGeom prst="rect">
-            <a:avLst/>
-          </a:prstGeom>
-          <a:noFill/>
-          <a:ln/>
-        </p:spPr>
-        <p:txBody>
-          <a:bodyPr wrap="square" rtlCol="0" anchor="ctr"/>
-          <a:lstStyle/>
+            <a:off x="274320" y="4683760"/>
+            <a:ext cx="11338560" cy="673100"/>
+          </a:xfrm>
+          <a:prstGeom prst="rect">
+            <a:avLst/>
+          </a:prstGeom>
+          <a:noFill/>
+          <a:ln/>
+        </p:spPr>
+        <p:txBody>
+          <a:bodyPr wrap="square" rtlCol="0" anchor="ctr"/>
+          <a:lstStyle/>
+          <a:p>
+            <a:pPr algn="ctr"/>
+            <a:r>
+              <a:rPr lang="ja-JP" altLang="en-US" sz="1300" b="1" dirty="0">
+                <a:solidFill>
+                  <a:srgbClr val="2D2012"/>
+                </a:solidFill>
+                <a:latin typeface="Yu Gothic" pitchFamily="34" charset="0"/>
+                <a:ea typeface="Yu Gothic" pitchFamily="34" charset="-122"/>
+                <a:cs typeface="Yu Gothic" pitchFamily="34" charset="-120"/>
+              </a:rPr>
+              <a:t>「</a:t>
+            </a:r>
+            <a:r>
+              <a:rPr lang="en-US" altLang="ja-JP" sz="1300" b="1" dirty="0">
+                <a:solidFill>
+                  <a:srgbClr val="2D2012"/>
+                </a:solidFill>
+                <a:latin typeface="Yu Gothic" pitchFamily="34" charset="0"/>
+                <a:ea typeface="Yu Gothic" pitchFamily="34" charset="-122"/>
+                <a:cs typeface="Yu Gothic" pitchFamily="34" charset="-120"/>
+              </a:rPr>
+              <a:t>tests/test-results.xlsx</a:t>
+            </a:r>
+            <a:r>
+              <a:rPr lang="ja-JP" altLang="en-US" sz="1300" b="1" dirty="0">
+                <a:solidFill>
+                  <a:srgbClr val="2D2012"/>
+                </a:solidFill>
+                <a:latin typeface="Yu Gothic" pitchFamily="34" charset="0"/>
+                <a:ea typeface="Yu Gothic" pitchFamily="34" charset="-122"/>
+                <a:cs typeface="Yu Gothic" pitchFamily="34" charset="-120"/>
+              </a:rPr>
+              <a:t>」をご参照ください</a:t>
+            </a:r>
+            <a:endParaRPr lang="en-US" sz="1300" b="1" dirty="0">
+              <a:solidFill>
+                <a:srgbClr val="2D2012"/>
+              </a:solidFill>
+              <a:latin typeface="Yu Gothic" pitchFamily="34" charset="0"/>
+              <a:ea typeface="Yu Gothic" pitchFamily="34" charset="-122"/>
+              <a:cs typeface="Yu Gothic" pitchFamily="34" charset="-120"/>
+            </a:endParaRPr>
+          </a:p>
           <a:p>
             <a:pPr marL="0" indent="0" algn="ctr">
               <a:buNone/>
             </a:pPr>
             <a:r>
-              <a:rPr lang="en-US" sz="1300" b="1" dirty="0">
+              <a:rPr lang="en-US" sz="1300" b="1" dirty="0" err="1">
                 <a:solidFill>
                   <a:srgbClr val="2D2012"/>
                 </a:solidFill>

</xml_diff>